<commit_message>
Session 7 reveals, printable sample proposals
- Session 7 deck: click reveals built from the outline's cues (slides 5,
  10, 11, 13, 14, 16, 18, 20, 26); slide 10 now shows the weak column
  first; slide 26's fatal arithmetic uses the 10 weeks actually left.
- Printable PDFs of the weak and strong sample proposals; the weak page
  links its copy, the strong one is instructor-only. Strong intro names
  the weak sample instead of "here".
- print-md.sh drops whole <file> lines (no dangling "Printable copy:")
  and takes PRINT_MD_EXTRA_CSS for per-document tweaks; Backstage PDF
  rebuilt clean.
- .gitignore: grading/ (student submissions and grading notes stay private).

Co-Authored-By: Claude Opus 5.5 (1M context) <noreply@anthropic.com>
</commit_message>
<xml_diff>
--- a/canvas_material/lectures/powerpoint/Session07-ProposalAnatomy.pptx
+++ b/canvas_material/lectures/powerpoint/Session07-ProposalAnatomy.pptx
@@ -619,7 +619,7 @@
           <a:p>
             <a:r>
               <a:rPr lang="en-US" dirty="0"/>
-              <a:t>Three minutes, demonstrated rather than asserted. Read the left column aloud, then the right, and let the room hear the difference — these are the actual opening sentences of the summary, problem, and solution sections of each proposal. The strong one's form a chain of claims that names a user and a tool; the weak one's are three moods in a row. Then give them the instruction they can act on tonight: after drafting, read only your first sentences in order. It takes two minutes and exposes buried arguments better than any amount of rereading.</a:t>
+              <a:t>Three minutes, demonstrated rather than asserted. Read the weak column aloud — the one they've read — then click to bring in Backstage's same three sentences, read those, and let the room hear the difference; the second click brings the verdict. These are the actual opening sentences of the summary, problem, and solution sections of each proposal. The weak one's are three moods in a row; the strong one's form a chain of claims that names a user and a tool. Then give them the instruction they can act on tonight: after drafting, read only your first sentences in order. It takes two minutes and exposes buried arguments better than any amount of rereading.</a:t>
             </a:r>
             <a:endParaRPr lang="en-US" dirty="0"/>
           </a:p>
@@ -707,7 +707,7 @@
           <a:p>
             <a:r>
               <a:rPr lang="en-US" dirty="0"/>
-              <a:t>Three minutes. Both failure directions come from the same place — uncertainty about whether the evidence carries the claim. Salesy language papers over it; apologetic language pre-apologizes for it. The fix is neither: state what you know, what you don't, and what you cut. End on the navy bar, because it's the bridge into the dissection: every weak passage they're about to see substitutes an adjective for a fact, and every strong one does the reverse.</a:t>
+              <a:t>Three minutes. Both failure directions come from the same place — uncertainty about whether the evidence carries the claim. Salesy language papers over it; apologetic language pre-apologizes for it. The fix is neither: state what you know, what you don't, and what you cut. Click to bring in the navy bar and end on it, because it's the bridge into the dissection: every weak passage they're about to see substitutes an adjective for a fact, and every strong one does the reverse.</a:t>
             </a:r>
             <a:endParaRPr lang="en-US" dirty="0"/>
           </a:p>
@@ -883,7 +883,7 @@
           <a:p>
             <a:r>
               <a:rPr lang="en-US" dirty="0"/>
-              <a:t>Ninety seconds, and it pays for itself all session. Students default to reactions — vague, confusing, too much — which feel like feedback but give the author nothing to change. Read the left column, ask the room to convert one before you show the right. Then land the bottom bar: the goal is a sentence the author could act on tonight. The rubric criteria are a convenient set of names and Wednesday's review is anchored to them, but a precise observation in plain words beats criterion jargon attached to a vague complaint. This is the same skill as a useful code-review comment.</a:t>
+              <a:t>Ninety seconds, and it pays for itself all session. Students default to reactions — vague, confusing, too much — which feel like feedback but give the author nothing to change. Read the left column, and ask the room to convert each one before you click to show the right — three clicks, one per row; the fourth brings the bottom bar. Then land the bottom bar: the goal is a sentence the author could act on tonight. The rubric criteria are a convenient set of names and Wednesday's review is anchored to them, but a precise observation in plain words beats criterion jargon attached to a vague complaint. This is the same skill as a useful code-review comment.</a:t>
             </a:r>
             <a:endParaRPr lang="en-US" dirty="0"/>
           </a:p>
@@ -971,7 +971,7 @@
           <a:p>
             <a:r>
               <a:rPr lang="en-US" dirty="0"/>
-              <a:t>Two minutes, and it is the orientation the rest of the dissection depends on — nobody in the room has read the strong proposal, so without this the excerpts arrive from nowhere. Read both aloud. Ask what each one told them: the right paragraph names a bounded user, an evidence count, a specific tool, a sized MVP, and four exclusions; the left names an adjective and a feature list. This also demonstrates the slide-5 claim on real text — the executive summary is written last because it can only compress an argument that already exists.</a:t>
+              <a:t>Two minutes, and it is the orientation the rest of the dissection depends on — nobody in the room has read the strong proposal, so without this the excerpts arrive from nowhere. Read both aloud. Ask what each one told them before you click in the bottom bar: the right paragraph names a bounded user, an evidence count, a specific tool, a sized MVP, and four exclusions; the left names an adjective and a feature list. This also demonstrates the slide-5 claim on real text — the executive summary is written last because it can only compress an argument that already exists.</a:t>
             </a:r>
             <a:endParaRPr lang="en-US" dirty="0"/>
           </a:p>
@@ -1147,7 +1147,7 @@
           <a:p>
             <a:r>
               <a:rPr lang="en-US" dirty="0"/>
-              <a:t>Now reveal. Walk the three moves: bounded users you could actually go find, needs ranked with an evidence count attached, and one concrete human doing a concrete thing. Then read the fourth line aloud — the author admits they only spoke to leads, not new volunteers. Ask the room whether that admission made them trust the document more or less. It's the credibility-economy lesson landing on a real example.</a:t>
+              <a:t>Now reveal. Ask what specifically changed before you click in the bottom band. Walk the three moves: bounded users you could actually go find, needs ranked with an evidence count attached, and one concrete human doing a concrete thing. Then read the fourth line aloud — the author admits they only spoke to leads, not new volunteers. Ask the room whether that admission made them trust the document more or less. It's the credibility-economy lesson landing on a real example.</a:t>
             </a:r>
             <a:endParaRPr lang="en-US" dirty="0"/>
           </a:p>
@@ -1323,7 +1323,7 @@
           <a:p>
             <a:r>
               <a:rPr lang="en-US" dirty="0"/>
-              <a:t>Reveal and compare reason-types side by side: adjectives on the left, constraints on the right — no IT staff, a box someone can operate, a venue with bad wifi. Constraints are checkable and specific to one project; adjectives are decoration. Then the spike: six hours converted 'photos might be too slow' into a design requirement that's now in the technical approach. Ask the direct question — which of these two authors knows whether their project is possible? Only one of them went and found out.</a:t>
+              <a:t>Reveal, and ask what changed before you click in the bottom band. Compare reason-types side by side: adjectives on the left, constraints on the right — no IT staff, a box someone can operate, a venue with bad wifi. Constraints are checkable and specific to one project; adjectives are decoration. Then the spike: six hours converted 'photos might be too slow' into a design requirement that's now in the technical approach. Ask the direct question — which of these two authors knows whether their project is possible? Only one of them went and found out.</a:t>
             </a:r>
             <a:endParaRPr lang="en-US" dirty="0"/>
           </a:p>
@@ -1587,7 +1587,7 @@
           <a:p>
             <a:r>
               <a:rPr lang="en-US" dirty="0"/>
-              <a:t>The 'it was in my first draft' sentence is the whole lesson about non-goals, so read it aloud. Naming a cut that hurt proves the author made a decision under real tension rather than listing things they never wanted. Then contrast the two MVPs: four features across four surfaces versus one workflow, one user type, end to end, on real data. Ask which one they'd believe a December demo from — and note that the modest one is also the more ambitious claim, because it's a promise rather than a wish.</a:t>
+              <a:t>Ask what changed before clicking in the bottom band. The 'it was in my first draft' sentence is the whole lesson about non-goals, so read it aloud. Naming a cut that hurt proves the author made a decision under real tension rather than listing things they never wanted. Then contrast the two MVPs: four features across four surfaces versus one workflow, one user type, end to end, on real data. Ask which one they'd believe a December demo from — and note that the modest one is also the more ambitious claim, because it's a promise rather than a wish.</a:t>
             </a:r>
             <a:endParaRPr lang="en-US" dirty="0"/>
           </a:p>
@@ -2115,7 +2115,7 @@
           <a:p>
             <a:r>
               <a:rPr lang="en-US" dirty="0"/>
-              <a:t>Stop and actually run the ninety seconds — do not just describe it. Have every student write two numbers on paper: honest hours per week, times five. The room goes quiet when the product lands well under what their draft promises, and that silence is worth more than another slide. Then name the payoff: scope realism is fifteen points, and reviewers reward it. Close on non-goals — the reader can't see features you never listed, only the ones you named and cut.</a:t>
+              <a:t>Four beats on clicks: the fatal version alone, then the honest version, then the amber do-it-now card, then the underpromise bar. Stop and actually run the ninety seconds — do not just describe it. Have every student write two numbers on paper: honest hours per week, times five. The room goes quiet when the product lands well under what their draft promises, and that silence is worth more than another slide. Then name the payoff: scope realism is fifteen points, and reviewers reward it. Close on non-goals — the reader can't see features you never listed, only the ones you named and cut.</a:t>
             </a:r>
             <a:endParaRPr lang="en-US" dirty="0"/>
           </a:p>
@@ -2731,7 +2731,7 @@
           <a:p>
             <a:r>
               <a:rPr lang="en-US" dirty="0"/>
-              <a:t>Seven minutes, and run it as recall — you read the reading, so tell me. Call on the room by section: what is non-goals FOR? Where does the material for technical approach come from? Two or three exchanges is enough; do not lecture the grid. The subtitles are the answers if the room stalls. If the entry poll went badly, this is where you spend three extra minutes — take them from the §4 buffer, never from the feasibility block.</a:t>
+              <a:t>Seven minutes, and run it as recall — you read the reading, so tell me. Call on the room by section: what is non-goals FOR? Where does the material for technical approach come from? Two or three exchanges is enough; do not lecture the grid. The subtitles are the answers — they stay hidden until you click, so take answers first and click only once the room has tried (or stalled). If the entry poll went badly, this is where you spend three extra minutes — take them from the §4 buffer, never from the feasibility block.</a:t>
             </a:r>
             <a:endParaRPr lang="en-US" dirty="0"/>
           </a:p>
@@ -3939,7 +3939,7 @@
             </a:avLst>
           </a:prstGeom>
           <a:solidFill>
-            <a:srgbClr val="EAF4EE"/>
+            <a:srgbClr val="FBECE8"/>
           </a:solidFill>
           <a:ln/>
           <a:effectLst>
@@ -3978,13 +3978,13 @@
             <a:r>
               <a:rPr lang="en-US" sz="1500" b="1" dirty="0">
                 <a:solidFill>
-                  <a:srgbClr val="0E6E6D"/>
-                </a:solidFill>
-                <a:latin typeface="Calibri" pitchFamily="34" charset="0"/>
-                <a:ea typeface="Calibri" pitchFamily="34" charset="-122"/>
-                <a:cs typeface="Calibri" pitchFamily="34" charset="-120"/>
-              </a:rPr>
-              <a:t>Backstage — first sentences: summary · problem · solution</a:t>
+                  <a:srgbClr val="D9614C"/>
+                </a:solidFill>
+                <a:latin typeface="Calibri" pitchFamily="34" charset="0"/>
+                <a:ea typeface="Calibri" pitchFamily="34" charset="-122"/>
+                <a:cs typeface="Calibri" pitchFamily="34" charset="-120"/>
+              </a:rPr>
+              <a:t>CostumeHub — summary · problem · solution</a:t>
             </a:r>
             <a:endParaRPr lang="en-US" sz="1500" dirty="0"/>
           </a:p>
@@ -4029,7 +4029,7 @@
                 <a:ea typeface="Calibri" pitchFamily="34" charset="-122"/>
                 <a:cs typeface="Calibri" pitchFamily="34" charset="-120"/>
               </a:rPr>
-              <a:t>Volunteer-run community theaters own thousands of costumes and track them in spiral notebooks and one volunteer's memory.</a:t>
+              <a:t>Costume management is a huge problem for theaters everywhere.</a:t>
             </a:r>
             <a:endParaRPr lang="en-US" sz="1500" dirty="0"/>
           </a:p>
@@ -4052,7 +4052,7 @@
                 <a:ea typeface="Calibri" pitchFamily="34" charset="-122"/>
                 <a:cs typeface="Calibri" pitchFamily="34" charset="-120"/>
               </a:rPr>
-              <a:t>Wardrobe and props volunteers at small, volunteer-run community theaters — one to three people per theater.</a:t>
+              <a:t>Theaters everywhere struggle to keep track of their costumes.</a:t>
             </a:r>
             <a:endParaRPr lang="en-US" sz="1500" dirty="0"/>
           </a:p>
@@ -4072,7 +4072,7 @@
                 <a:ea typeface="Calibri" pitchFamily="34" charset="-122"/>
                 <a:cs typeface="Calibri" pitchFamily="34" charset="-120"/>
               </a:rPr>
-              <a:t>A phone-first web catalog for one theater's collection.</a:t>
+              <a:t>CostumeHub will be a complete, modern platform for costume management.</a:t>
             </a:r>
             <a:endParaRPr lang="en-US" sz="1500" dirty="0"/>
           </a:p>
@@ -4080,7 +4080,7 @@
       </p:sp>
       <p:sp>
         <p:nvSpPr>
-          <p:cNvPr id="12" name="Shape 9"/>
+          <p:cNvPr id="12" name="click-1"/>
           <p:cNvSpPr/>
           <p:nvPr/>
         </p:nvSpPr>
@@ -4095,7 +4095,7 @@
             </a:avLst>
           </a:prstGeom>
           <a:solidFill>
-            <a:srgbClr val="FBECE8"/>
+            <a:srgbClr val="EAF4EE"/>
           </a:solidFill>
           <a:ln/>
           <a:effectLst>
@@ -4109,7 +4109,7 @@
       </p:sp>
       <p:sp>
         <p:nvSpPr>
-          <p:cNvPr id="13" name="Text 10"/>
+          <p:cNvPr id="13" name="click-1"/>
           <p:cNvSpPr/>
           <p:nvPr/>
         </p:nvSpPr>
@@ -4134,13 +4134,13 @@
             <a:r>
               <a:rPr lang="en-US" sz="1500" b="1" dirty="0">
                 <a:solidFill>
-                  <a:srgbClr val="D9614C"/>
-                </a:solidFill>
-                <a:latin typeface="Calibri" pitchFamily="34" charset="0"/>
-                <a:ea typeface="Calibri" pitchFamily="34" charset="-122"/>
-                <a:cs typeface="Calibri" pitchFamily="34" charset="-120"/>
-              </a:rPr>
-              <a:t>CostumeHub — the same three sentences</a:t>
+                  <a:srgbClr val="0E6E6D"/>
+                </a:solidFill>
+                <a:latin typeface="Calibri" pitchFamily="34" charset="0"/>
+                <a:ea typeface="Calibri" pitchFamily="34" charset="-122"/>
+                <a:cs typeface="Calibri" pitchFamily="34" charset="-120"/>
+              </a:rPr>
+              <a:t>Backstage — the same three sentences</a:t>
             </a:r>
             <a:endParaRPr lang="en-US" sz="1500" dirty="0"/>
           </a:p>
@@ -4148,7 +4148,7 @@
       </p:sp>
       <p:sp>
         <p:nvSpPr>
-          <p:cNvPr id="14" name="Text 11"/>
+          <p:cNvPr id="14" name="click-1"/>
           <p:cNvSpPr/>
           <p:nvPr/>
         </p:nvSpPr>
@@ -4185,7 +4185,7 @@
                 <a:ea typeface="Calibri" pitchFamily="34" charset="-122"/>
                 <a:cs typeface="Calibri" pitchFamily="34" charset="-120"/>
               </a:rPr>
-              <a:t>Costume management is a huge problem for theaters everywhere.</a:t>
+              <a:t>Volunteer-run community theaters own thousands of costumes and track them in spiral notebooks and one volunteer's memory.</a:t>
             </a:r>
             <a:endParaRPr lang="en-US" sz="1500" dirty="0"/>
           </a:p>
@@ -4208,7 +4208,7 @@
                 <a:ea typeface="Calibri" pitchFamily="34" charset="-122"/>
                 <a:cs typeface="Calibri" pitchFamily="34" charset="-120"/>
               </a:rPr>
-              <a:t>Theaters everywhere struggle to keep track of their costumes.</a:t>
+              <a:t>Wardrobe and props volunteers at small, volunteer-run community theaters — one to three people per theater.</a:t>
             </a:r>
             <a:endParaRPr lang="en-US" sz="1500" dirty="0"/>
           </a:p>
@@ -4228,7 +4228,7 @@
                 <a:ea typeface="Calibri" pitchFamily="34" charset="-122"/>
                 <a:cs typeface="Calibri" pitchFamily="34" charset="-120"/>
               </a:rPr>
-              <a:t>CostumeHub will be a complete, modern platform for costume management.</a:t>
+              <a:t>A phone-first web catalog for one theater's collection.</a:t>
             </a:r>
             <a:endParaRPr lang="en-US" sz="1500" dirty="0"/>
           </a:p>
@@ -4236,7 +4236,7 @@
       </p:sp>
       <p:sp>
         <p:nvSpPr>
-          <p:cNvPr id="15" name="Shape 12"/>
+          <p:cNvPr id="15" name="click-2"/>
           <p:cNvSpPr/>
           <p:nvPr/>
         </p:nvSpPr>
@@ -4265,7 +4265,7 @@
       </p:sp>
       <p:sp>
         <p:nvSpPr>
-          <p:cNvPr id="16" name="Text 13"/>
+          <p:cNvPr id="16" name="click-2"/>
           <p:cNvSpPr/>
           <p:nvPr/>
         </p:nvSpPr>
@@ -4405,6 +4405,214 @@
   <p:clrMapOvr>
     <a:masterClrMapping/>
   </p:clrMapOvr>
+  <p:timing>
+    <p:tnLst>
+      <p:par>
+        <p:cTn id="1" dur="indefinite" restart="never" nodeType="tmRoot">
+          <p:childTnLst>
+            <p:seq concurrent="1" nextAc="seek">
+              <p:cTn id="2" dur="indefinite" nodeType="mainSeq">
+                <p:childTnLst>
+                  <p:par>
+                    <p:cTn id="3" fill="hold">
+                      <p:stCondLst>
+                        <p:cond delay="indefinite"/>
+                      </p:stCondLst>
+                      <p:childTnLst>
+                        <p:par>
+                          <p:cTn id="4" fill="hold">
+                            <p:stCondLst>
+                              <p:cond delay="0"/>
+                            </p:stCondLst>
+                            <p:childTnLst>
+                              <p:par>
+                                <p:cTn id="6" presetID="1" presetClass="entr" presetSubtype="0" fill="hold" grpId="0" nodeType="clickEffect">
+                                  <p:stCondLst>
+                                    <p:cond delay="0"/>
+                                  </p:stCondLst>
+                                  <p:childTnLst>
+                                    <p:set>
+                                      <p:cBhvr>
+                                        <p:cTn id="5" dur="1" fill="hold">
+                                          <p:stCondLst>
+                                            <p:cond delay="0"/>
+                                          </p:stCondLst>
+                                        </p:cTn>
+                                        <p:tgtEl>
+                                          <p:spTgt spid="12"/>
+                                        </p:tgtEl>
+                                        <p:attrNameLst>
+                                          <p:attrName>style.visibility</p:attrName>
+                                        </p:attrNameLst>
+                                      </p:cBhvr>
+                                      <p:to>
+                                        <p:strVal val="visible"/>
+                                      </p:to>
+                                    </p:set>
+                                  </p:childTnLst>
+                                </p:cTn>
+                              </p:par>
+                              <p:par>
+                                <p:cTn id="8" presetID="1" presetClass="entr" presetSubtype="0" fill="hold" grpId="0" nodeType="withEffect">
+                                  <p:stCondLst>
+                                    <p:cond delay="0"/>
+                                  </p:stCondLst>
+                                  <p:childTnLst>
+                                    <p:set>
+                                      <p:cBhvr>
+                                        <p:cTn id="7" dur="1" fill="hold">
+                                          <p:stCondLst>
+                                            <p:cond delay="0"/>
+                                          </p:stCondLst>
+                                        </p:cTn>
+                                        <p:tgtEl>
+                                          <p:spTgt spid="13"/>
+                                        </p:tgtEl>
+                                        <p:attrNameLst>
+                                          <p:attrName>style.visibility</p:attrName>
+                                        </p:attrNameLst>
+                                      </p:cBhvr>
+                                      <p:to>
+                                        <p:strVal val="visible"/>
+                                      </p:to>
+                                    </p:set>
+                                  </p:childTnLst>
+                                </p:cTn>
+                              </p:par>
+                              <p:par>
+                                <p:cTn id="10" presetID="1" presetClass="entr" presetSubtype="0" fill="hold" grpId="0" nodeType="withEffect">
+                                  <p:stCondLst>
+                                    <p:cond delay="0"/>
+                                  </p:stCondLst>
+                                  <p:childTnLst>
+                                    <p:set>
+                                      <p:cBhvr>
+                                        <p:cTn id="9" dur="1" fill="hold">
+                                          <p:stCondLst>
+                                            <p:cond delay="0"/>
+                                          </p:stCondLst>
+                                        </p:cTn>
+                                        <p:tgtEl>
+                                          <p:spTgt spid="14"/>
+                                        </p:tgtEl>
+                                        <p:attrNameLst>
+                                          <p:attrName>style.visibility</p:attrName>
+                                        </p:attrNameLst>
+                                      </p:cBhvr>
+                                      <p:to>
+                                        <p:strVal val="visible"/>
+                                      </p:to>
+                                    </p:set>
+                                  </p:childTnLst>
+                                </p:cTn>
+                              </p:par>
+                            </p:childTnLst>
+                          </p:cTn>
+                        </p:par>
+                      </p:childTnLst>
+                    </p:cTn>
+                  </p:par>
+                  <p:par>
+                    <p:cTn id="11" fill="hold">
+                      <p:stCondLst>
+                        <p:cond delay="indefinite"/>
+                      </p:stCondLst>
+                      <p:childTnLst>
+                        <p:par>
+                          <p:cTn id="12" fill="hold">
+                            <p:stCondLst>
+                              <p:cond delay="0"/>
+                            </p:stCondLst>
+                            <p:childTnLst>
+                              <p:par>
+                                <p:cTn id="14" presetID="1" presetClass="entr" presetSubtype="0" fill="hold" grpId="0" nodeType="clickEffect">
+                                  <p:stCondLst>
+                                    <p:cond delay="0"/>
+                                  </p:stCondLst>
+                                  <p:childTnLst>
+                                    <p:set>
+                                      <p:cBhvr>
+                                        <p:cTn id="13" dur="1" fill="hold">
+                                          <p:stCondLst>
+                                            <p:cond delay="0"/>
+                                          </p:stCondLst>
+                                        </p:cTn>
+                                        <p:tgtEl>
+                                          <p:spTgt spid="15"/>
+                                        </p:tgtEl>
+                                        <p:attrNameLst>
+                                          <p:attrName>style.visibility</p:attrName>
+                                        </p:attrNameLst>
+                                      </p:cBhvr>
+                                      <p:to>
+                                        <p:strVal val="visible"/>
+                                      </p:to>
+                                    </p:set>
+                                  </p:childTnLst>
+                                </p:cTn>
+                              </p:par>
+                              <p:par>
+                                <p:cTn id="16" presetID="1" presetClass="entr" presetSubtype="0" fill="hold" grpId="0" nodeType="withEffect">
+                                  <p:stCondLst>
+                                    <p:cond delay="0"/>
+                                  </p:stCondLst>
+                                  <p:childTnLst>
+                                    <p:set>
+                                      <p:cBhvr>
+                                        <p:cTn id="15" dur="1" fill="hold">
+                                          <p:stCondLst>
+                                            <p:cond delay="0"/>
+                                          </p:stCondLst>
+                                        </p:cTn>
+                                        <p:tgtEl>
+                                          <p:spTgt spid="16"/>
+                                        </p:tgtEl>
+                                        <p:attrNameLst>
+                                          <p:attrName>style.visibility</p:attrName>
+                                        </p:attrNameLst>
+                                      </p:cBhvr>
+                                      <p:to>
+                                        <p:strVal val="visible"/>
+                                      </p:to>
+                                    </p:set>
+                                  </p:childTnLst>
+                                </p:cTn>
+                              </p:par>
+                            </p:childTnLst>
+                          </p:cTn>
+                        </p:par>
+                      </p:childTnLst>
+                    </p:cTn>
+                  </p:par>
+                </p:childTnLst>
+              </p:cTn>
+              <p:prevCondLst>
+                <p:cond evt="onPrev" delay="0">
+                  <p:tgtEl>
+                    <p:sldTgt/>
+                  </p:tgtEl>
+                </p:cond>
+              </p:prevCondLst>
+              <p:nextCondLst>
+                <p:cond evt="onNext" delay="0">
+                  <p:tgtEl>
+                    <p:sldTgt/>
+                  </p:tgtEl>
+                </p:cond>
+              </p:nextCondLst>
+            </p:seq>
+          </p:childTnLst>
+        </p:cTn>
+      </p:par>
+    </p:tnLst>
+    <p:bldLst>
+      <p:bldP spid="12" grpId="0" animBg="1"/>
+      <p:bldP spid="13" grpId="0" animBg="1"/>
+      <p:bldP spid="14" grpId="0" animBg="1"/>
+      <p:bldP spid="15" grpId="0" animBg="1"/>
+      <p:bldP spid="16" grpId="0" animBg="1"/>
+    </p:bldLst>
+  </p:timing>
 </p:sld>
 </file>
 
@@ -5012,7 +5220,7 @@
       </p:sp>
       <p:sp>
         <p:nvSpPr>
-          <p:cNvPr id="19" name="Shape 14"/>
+          <p:cNvPr id="19" name="click-1"/>
           <p:cNvSpPr/>
           <p:nvPr/>
         </p:nvSpPr>
@@ -5041,7 +5249,7 @@
       </p:sp>
       <p:sp>
         <p:nvSpPr>
-          <p:cNvPr id="20" name="Text 15"/>
+          <p:cNvPr id="20" name="click-1"/>
           <p:cNvSpPr/>
           <p:nvPr/>
         </p:nvSpPr>
@@ -5175,6 +5383,112 @@
   <p:clrMapOvr>
     <a:masterClrMapping/>
   </p:clrMapOvr>
+  <p:timing>
+    <p:tnLst>
+      <p:par>
+        <p:cTn id="1" dur="indefinite" restart="never" nodeType="tmRoot">
+          <p:childTnLst>
+            <p:seq concurrent="1" nextAc="seek">
+              <p:cTn id="2" dur="indefinite" nodeType="mainSeq">
+                <p:childTnLst>
+                  <p:par>
+                    <p:cTn id="3" fill="hold">
+                      <p:stCondLst>
+                        <p:cond delay="indefinite"/>
+                      </p:stCondLst>
+                      <p:childTnLst>
+                        <p:par>
+                          <p:cTn id="4" fill="hold">
+                            <p:stCondLst>
+                              <p:cond delay="0"/>
+                            </p:stCondLst>
+                            <p:childTnLst>
+                              <p:par>
+                                <p:cTn id="6" presetID="1" presetClass="entr" presetSubtype="0" fill="hold" grpId="0" nodeType="clickEffect">
+                                  <p:stCondLst>
+                                    <p:cond delay="0"/>
+                                  </p:stCondLst>
+                                  <p:childTnLst>
+                                    <p:set>
+                                      <p:cBhvr>
+                                        <p:cTn id="5" dur="1" fill="hold">
+                                          <p:stCondLst>
+                                            <p:cond delay="0"/>
+                                          </p:stCondLst>
+                                        </p:cTn>
+                                        <p:tgtEl>
+                                          <p:spTgt spid="19"/>
+                                        </p:tgtEl>
+                                        <p:attrNameLst>
+                                          <p:attrName>style.visibility</p:attrName>
+                                        </p:attrNameLst>
+                                      </p:cBhvr>
+                                      <p:to>
+                                        <p:strVal val="visible"/>
+                                      </p:to>
+                                    </p:set>
+                                  </p:childTnLst>
+                                </p:cTn>
+                              </p:par>
+                              <p:par>
+                                <p:cTn id="8" presetID="1" presetClass="entr" presetSubtype="0" fill="hold" grpId="0" nodeType="withEffect">
+                                  <p:stCondLst>
+                                    <p:cond delay="0"/>
+                                  </p:stCondLst>
+                                  <p:childTnLst>
+                                    <p:set>
+                                      <p:cBhvr>
+                                        <p:cTn id="7" dur="1" fill="hold">
+                                          <p:stCondLst>
+                                            <p:cond delay="0"/>
+                                          </p:stCondLst>
+                                        </p:cTn>
+                                        <p:tgtEl>
+                                          <p:spTgt spid="20"/>
+                                        </p:tgtEl>
+                                        <p:attrNameLst>
+                                          <p:attrName>style.visibility</p:attrName>
+                                        </p:attrNameLst>
+                                      </p:cBhvr>
+                                      <p:to>
+                                        <p:strVal val="visible"/>
+                                      </p:to>
+                                    </p:set>
+                                  </p:childTnLst>
+                                </p:cTn>
+                              </p:par>
+                            </p:childTnLst>
+                          </p:cTn>
+                        </p:par>
+                      </p:childTnLst>
+                    </p:cTn>
+                  </p:par>
+                </p:childTnLst>
+              </p:cTn>
+              <p:prevCondLst>
+                <p:cond evt="onPrev" delay="0">
+                  <p:tgtEl>
+                    <p:sldTgt/>
+                  </p:tgtEl>
+                </p:cond>
+              </p:prevCondLst>
+              <p:nextCondLst>
+                <p:cond evt="onNext" delay="0">
+                  <p:tgtEl>
+                    <p:sldTgt/>
+                  </p:tgtEl>
+                </p:cond>
+              </p:nextCondLst>
+            </p:seq>
+          </p:childTnLst>
+        </p:cTn>
+      </p:par>
+    </p:tnLst>
+    <p:bldLst>
+      <p:bldP spid="19" grpId="0" animBg="1"/>
+      <p:bldP spid="20" grpId="0" animBg="1"/>
+    </p:bldLst>
+  </p:timing>
 </p:sld>
 </file>
 
@@ -6149,7 +6463,7 @@
       </p:sp>
       <p:sp>
         <p:nvSpPr>
-          <p:cNvPr id="8" name="Shape 6"/>
+          <p:cNvPr id="8" name="click-1"/>
           <p:cNvSpPr/>
           <p:nvPr/>
         </p:nvSpPr>
@@ -6169,7 +6483,7 @@
       </p:sp>
       <p:pic>
         <p:nvPicPr>
-          <p:cNvPr id="9" name="Image 0" descr="preencoded.png">    </p:cNvPr>
+          <p:cNvPr id="9" name="click-1" descr="preencoded.png">    </p:cNvPr>
           <p:cNvPicPr>
             <a:picLocks noChangeAspect="1"/>
           </p:cNvPicPr>
@@ -6193,7 +6507,7 @@
       </p:pic>
       <p:sp>
         <p:nvSpPr>
-          <p:cNvPr id="10" name="Shape 7"/>
+          <p:cNvPr id="10" name="click-1"/>
           <p:cNvSpPr/>
           <p:nvPr/>
         </p:nvSpPr>
@@ -6222,7 +6536,7 @@
       </p:sp>
       <p:sp>
         <p:nvSpPr>
-          <p:cNvPr id="11" name="Text 8"/>
+          <p:cNvPr id="11" name="click-1"/>
           <p:cNvSpPr/>
           <p:nvPr/>
         </p:nvSpPr>
@@ -6335,7 +6649,7 @@
       </p:sp>
       <p:sp>
         <p:nvSpPr>
-          <p:cNvPr id="14" name="Shape 11"/>
+          <p:cNvPr id="14" name="click-2"/>
           <p:cNvSpPr/>
           <p:nvPr/>
         </p:nvSpPr>
@@ -6355,7 +6669,7 @@
       </p:sp>
       <p:pic>
         <p:nvPicPr>
-          <p:cNvPr id="15" name="Image 1" descr="preencoded.png">    </p:cNvPr>
+          <p:cNvPr id="15" name="click-2" descr="preencoded.png">    </p:cNvPr>
           <p:cNvPicPr>
             <a:picLocks noChangeAspect="1"/>
           </p:cNvPicPr>
@@ -6379,7 +6693,7 @@
       </p:pic>
       <p:sp>
         <p:nvSpPr>
-          <p:cNvPr id="16" name="Shape 12"/>
+          <p:cNvPr id="16" name="click-2"/>
           <p:cNvSpPr/>
           <p:nvPr/>
         </p:nvSpPr>
@@ -6408,7 +6722,7 @@
       </p:sp>
       <p:sp>
         <p:nvSpPr>
-          <p:cNvPr id="17" name="Text 13"/>
+          <p:cNvPr id="17" name="click-2"/>
           <p:cNvSpPr/>
           <p:nvPr/>
         </p:nvSpPr>
@@ -6521,7 +6835,7 @@
       </p:sp>
       <p:sp>
         <p:nvSpPr>
-          <p:cNvPr id="20" name="Shape 16"/>
+          <p:cNvPr id="20" name="click-3"/>
           <p:cNvSpPr/>
           <p:nvPr/>
         </p:nvSpPr>
@@ -6541,7 +6855,7 @@
       </p:sp>
       <p:pic>
         <p:nvPicPr>
-          <p:cNvPr id="21" name="Image 2" descr="preencoded.png">    </p:cNvPr>
+          <p:cNvPr id="21" name="click-3" descr="preencoded.png">    </p:cNvPr>
           <p:cNvPicPr>
             <a:picLocks noChangeAspect="1"/>
           </p:cNvPicPr>
@@ -6565,7 +6879,7 @@
       </p:pic>
       <p:sp>
         <p:nvSpPr>
-          <p:cNvPr id="22" name="Shape 17"/>
+          <p:cNvPr id="22" name="click-3"/>
           <p:cNvSpPr/>
           <p:nvPr/>
         </p:nvSpPr>
@@ -6594,7 +6908,7 @@
       </p:sp>
       <p:sp>
         <p:nvSpPr>
-          <p:cNvPr id="23" name="Text 18"/>
+          <p:cNvPr id="23" name="click-3"/>
           <p:cNvSpPr/>
           <p:nvPr/>
         </p:nvSpPr>
@@ -6636,7 +6950,7 @@
       </p:sp>
       <p:sp>
         <p:nvSpPr>
-          <p:cNvPr id="24" name="Shape 19"/>
+          <p:cNvPr id="24" name="click-4"/>
           <p:cNvSpPr/>
           <p:nvPr/>
         </p:nvSpPr>
@@ -6665,7 +6979,7 @@
       </p:sp>
       <p:sp>
         <p:nvSpPr>
-          <p:cNvPr id="25" name="Shape 20"/>
+          <p:cNvPr id="25" name="click-4"/>
           <p:cNvSpPr/>
           <p:nvPr/>
         </p:nvSpPr>
@@ -6685,7 +6999,7 @@
       </p:sp>
       <p:pic>
         <p:nvPicPr>
-          <p:cNvPr id="26" name="Image 3" descr="preencoded.png">    </p:cNvPr>
+          <p:cNvPr id="26" name="click-4" descr="preencoded.png">    </p:cNvPr>
           <p:cNvPicPr>
             <a:picLocks noChangeAspect="1"/>
           </p:cNvPicPr>
@@ -6709,7 +7023,7 @@
       </p:pic>
       <p:sp>
         <p:nvSpPr>
-          <p:cNvPr id="27" name="Text 21"/>
+          <p:cNvPr id="27" name="click-4"/>
           <p:cNvSpPr/>
           <p:nvPr/>
         </p:nvSpPr>
@@ -6849,6 +7163,554 @@
   <p:clrMapOvr>
     <a:masterClrMapping/>
   </p:clrMapOvr>
+  <p:timing>
+    <p:tnLst>
+      <p:par>
+        <p:cTn id="1" dur="indefinite" restart="never" nodeType="tmRoot">
+          <p:childTnLst>
+            <p:seq concurrent="1" nextAc="seek">
+              <p:cTn id="2" dur="indefinite" nodeType="mainSeq">
+                <p:childTnLst>
+                  <p:par>
+                    <p:cTn id="3" fill="hold">
+                      <p:stCondLst>
+                        <p:cond delay="indefinite"/>
+                      </p:stCondLst>
+                      <p:childTnLst>
+                        <p:par>
+                          <p:cTn id="4" fill="hold">
+                            <p:stCondLst>
+                              <p:cond delay="0"/>
+                            </p:stCondLst>
+                            <p:childTnLst>
+                              <p:par>
+                                <p:cTn id="6" presetID="1" presetClass="entr" presetSubtype="0" fill="hold" grpId="0" nodeType="clickEffect">
+                                  <p:stCondLst>
+                                    <p:cond delay="0"/>
+                                  </p:stCondLst>
+                                  <p:childTnLst>
+                                    <p:set>
+                                      <p:cBhvr>
+                                        <p:cTn id="5" dur="1" fill="hold">
+                                          <p:stCondLst>
+                                            <p:cond delay="0"/>
+                                          </p:stCondLst>
+                                        </p:cTn>
+                                        <p:tgtEl>
+                                          <p:spTgt spid="8"/>
+                                        </p:tgtEl>
+                                        <p:attrNameLst>
+                                          <p:attrName>style.visibility</p:attrName>
+                                        </p:attrNameLst>
+                                      </p:cBhvr>
+                                      <p:to>
+                                        <p:strVal val="visible"/>
+                                      </p:to>
+                                    </p:set>
+                                  </p:childTnLst>
+                                </p:cTn>
+                              </p:par>
+                              <p:par>
+                                <p:cTn id="8" presetID="1" presetClass="entr" presetSubtype="0" fill="hold" nodeType="withEffect">
+                                  <p:stCondLst>
+                                    <p:cond delay="0"/>
+                                  </p:stCondLst>
+                                  <p:childTnLst>
+                                    <p:set>
+                                      <p:cBhvr>
+                                        <p:cTn id="7" dur="1" fill="hold">
+                                          <p:stCondLst>
+                                            <p:cond delay="0"/>
+                                          </p:stCondLst>
+                                        </p:cTn>
+                                        <p:tgtEl>
+                                          <p:spTgt spid="9"/>
+                                        </p:tgtEl>
+                                        <p:attrNameLst>
+                                          <p:attrName>style.visibility</p:attrName>
+                                        </p:attrNameLst>
+                                      </p:cBhvr>
+                                      <p:to>
+                                        <p:strVal val="visible"/>
+                                      </p:to>
+                                    </p:set>
+                                  </p:childTnLst>
+                                </p:cTn>
+                              </p:par>
+                              <p:par>
+                                <p:cTn id="10" presetID="1" presetClass="entr" presetSubtype="0" fill="hold" grpId="0" nodeType="withEffect">
+                                  <p:stCondLst>
+                                    <p:cond delay="0"/>
+                                  </p:stCondLst>
+                                  <p:childTnLst>
+                                    <p:set>
+                                      <p:cBhvr>
+                                        <p:cTn id="9" dur="1" fill="hold">
+                                          <p:stCondLst>
+                                            <p:cond delay="0"/>
+                                          </p:stCondLst>
+                                        </p:cTn>
+                                        <p:tgtEl>
+                                          <p:spTgt spid="10"/>
+                                        </p:tgtEl>
+                                        <p:attrNameLst>
+                                          <p:attrName>style.visibility</p:attrName>
+                                        </p:attrNameLst>
+                                      </p:cBhvr>
+                                      <p:to>
+                                        <p:strVal val="visible"/>
+                                      </p:to>
+                                    </p:set>
+                                  </p:childTnLst>
+                                </p:cTn>
+                              </p:par>
+                              <p:par>
+                                <p:cTn id="12" presetID="1" presetClass="entr" presetSubtype="0" fill="hold" grpId="0" nodeType="withEffect">
+                                  <p:stCondLst>
+                                    <p:cond delay="0"/>
+                                  </p:stCondLst>
+                                  <p:childTnLst>
+                                    <p:set>
+                                      <p:cBhvr>
+                                        <p:cTn id="11" dur="1" fill="hold">
+                                          <p:stCondLst>
+                                            <p:cond delay="0"/>
+                                          </p:stCondLst>
+                                        </p:cTn>
+                                        <p:tgtEl>
+                                          <p:spTgt spid="11"/>
+                                        </p:tgtEl>
+                                        <p:attrNameLst>
+                                          <p:attrName>style.visibility</p:attrName>
+                                        </p:attrNameLst>
+                                      </p:cBhvr>
+                                      <p:to>
+                                        <p:strVal val="visible"/>
+                                      </p:to>
+                                    </p:set>
+                                  </p:childTnLst>
+                                </p:cTn>
+                              </p:par>
+                            </p:childTnLst>
+                          </p:cTn>
+                        </p:par>
+                      </p:childTnLst>
+                    </p:cTn>
+                  </p:par>
+                  <p:par>
+                    <p:cTn id="13" fill="hold">
+                      <p:stCondLst>
+                        <p:cond delay="indefinite"/>
+                      </p:stCondLst>
+                      <p:childTnLst>
+                        <p:par>
+                          <p:cTn id="14" fill="hold">
+                            <p:stCondLst>
+                              <p:cond delay="0"/>
+                            </p:stCondLst>
+                            <p:childTnLst>
+                              <p:par>
+                                <p:cTn id="16" presetID="1" presetClass="entr" presetSubtype="0" fill="hold" grpId="0" nodeType="clickEffect">
+                                  <p:stCondLst>
+                                    <p:cond delay="0"/>
+                                  </p:stCondLst>
+                                  <p:childTnLst>
+                                    <p:set>
+                                      <p:cBhvr>
+                                        <p:cTn id="15" dur="1" fill="hold">
+                                          <p:stCondLst>
+                                            <p:cond delay="0"/>
+                                          </p:stCondLst>
+                                        </p:cTn>
+                                        <p:tgtEl>
+                                          <p:spTgt spid="14"/>
+                                        </p:tgtEl>
+                                        <p:attrNameLst>
+                                          <p:attrName>style.visibility</p:attrName>
+                                        </p:attrNameLst>
+                                      </p:cBhvr>
+                                      <p:to>
+                                        <p:strVal val="visible"/>
+                                      </p:to>
+                                    </p:set>
+                                  </p:childTnLst>
+                                </p:cTn>
+                              </p:par>
+                              <p:par>
+                                <p:cTn id="18" presetID="1" presetClass="entr" presetSubtype="0" fill="hold" nodeType="withEffect">
+                                  <p:stCondLst>
+                                    <p:cond delay="0"/>
+                                  </p:stCondLst>
+                                  <p:childTnLst>
+                                    <p:set>
+                                      <p:cBhvr>
+                                        <p:cTn id="17" dur="1" fill="hold">
+                                          <p:stCondLst>
+                                            <p:cond delay="0"/>
+                                          </p:stCondLst>
+                                        </p:cTn>
+                                        <p:tgtEl>
+                                          <p:spTgt spid="15"/>
+                                        </p:tgtEl>
+                                        <p:attrNameLst>
+                                          <p:attrName>style.visibility</p:attrName>
+                                        </p:attrNameLst>
+                                      </p:cBhvr>
+                                      <p:to>
+                                        <p:strVal val="visible"/>
+                                      </p:to>
+                                    </p:set>
+                                  </p:childTnLst>
+                                </p:cTn>
+                              </p:par>
+                              <p:par>
+                                <p:cTn id="20" presetID="1" presetClass="entr" presetSubtype="0" fill="hold" grpId="0" nodeType="withEffect">
+                                  <p:stCondLst>
+                                    <p:cond delay="0"/>
+                                  </p:stCondLst>
+                                  <p:childTnLst>
+                                    <p:set>
+                                      <p:cBhvr>
+                                        <p:cTn id="19" dur="1" fill="hold">
+                                          <p:stCondLst>
+                                            <p:cond delay="0"/>
+                                          </p:stCondLst>
+                                        </p:cTn>
+                                        <p:tgtEl>
+                                          <p:spTgt spid="16"/>
+                                        </p:tgtEl>
+                                        <p:attrNameLst>
+                                          <p:attrName>style.visibility</p:attrName>
+                                        </p:attrNameLst>
+                                      </p:cBhvr>
+                                      <p:to>
+                                        <p:strVal val="visible"/>
+                                      </p:to>
+                                    </p:set>
+                                  </p:childTnLst>
+                                </p:cTn>
+                              </p:par>
+                              <p:par>
+                                <p:cTn id="22" presetID="1" presetClass="entr" presetSubtype="0" fill="hold" grpId="0" nodeType="withEffect">
+                                  <p:stCondLst>
+                                    <p:cond delay="0"/>
+                                  </p:stCondLst>
+                                  <p:childTnLst>
+                                    <p:set>
+                                      <p:cBhvr>
+                                        <p:cTn id="21" dur="1" fill="hold">
+                                          <p:stCondLst>
+                                            <p:cond delay="0"/>
+                                          </p:stCondLst>
+                                        </p:cTn>
+                                        <p:tgtEl>
+                                          <p:spTgt spid="17"/>
+                                        </p:tgtEl>
+                                        <p:attrNameLst>
+                                          <p:attrName>style.visibility</p:attrName>
+                                        </p:attrNameLst>
+                                      </p:cBhvr>
+                                      <p:to>
+                                        <p:strVal val="visible"/>
+                                      </p:to>
+                                    </p:set>
+                                  </p:childTnLst>
+                                </p:cTn>
+                              </p:par>
+                            </p:childTnLst>
+                          </p:cTn>
+                        </p:par>
+                      </p:childTnLst>
+                    </p:cTn>
+                  </p:par>
+                  <p:par>
+                    <p:cTn id="23" fill="hold">
+                      <p:stCondLst>
+                        <p:cond delay="indefinite"/>
+                      </p:stCondLst>
+                      <p:childTnLst>
+                        <p:par>
+                          <p:cTn id="24" fill="hold">
+                            <p:stCondLst>
+                              <p:cond delay="0"/>
+                            </p:stCondLst>
+                            <p:childTnLst>
+                              <p:par>
+                                <p:cTn id="26" presetID="1" presetClass="entr" presetSubtype="0" fill="hold" grpId="0" nodeType="clickEffect">
+                                  <p:stCondLst>
+                                    <p:cond delay="0"/>
+                                  </p:stCondLst>
+                                  <p:childTnLst>
+                                    <p:set>
+                                      <p:cBhvr>
+                                        <p:cTn id="25" dur="1" fill="hold">
+                                          <p:stCondLst>
+                                            <p:cond delay="0"/>
+                                          </p:stCondLst>
+                                        </p:cTn>
+                                        <p:tgtEl>
+                                          <p:spTgt spid="20"/>
+                                        </p:tgtEl>
+                                        <p:attrNameLst>
+                                          <p:attrName>style.visibility</p:attrName>
+                                        </p:attrNameLst>
+                                      </p:cBhvr>
+                                      <p:to>
+                                        <p:strVal val="visible"/>
+                                      </p:to>
+                                    </p:set>
+                                  </p:childTnLst>
+                                </p:cTn>
+                              </p:par>
+                              <p:par>
+                                <p:cTn id="28" presetID="1" presetClass="entr" presetSubtype="0" fill="hold" nodeType="withEffect">
+                                  <p:stCondLst>
+                                    <p:cond delay="0"/>
+                                  </p:stCondLst>
+                                  <p:childTnLst>
+                                    <p:set>
+                                      <p:cBhvr>
+                                        <p:cTn id="27" dur="1" fill="hold">
+                                          <p:stCondLst>
+                                            <p:cond delay="0"/>
+                                          </p:stCondLst>
+                                        </p:cTn>
+                                        <p:tgtEl>
+                                          <p:spTgt spid="21"/>
+                                        </p:tgtEl>
+                                        <p:attrNameLst>
+                                          <p:attrName>style.visibility</p:attrName>
+                                        </p:attrNameLst>
+                                      </p:cBhvr>
+                                      <p:to>
+                                        <p:strVal val="visible"/>
+                                      </p:to>
+                                    </p:set>
+                                  </p:childTnLst>
+                                </p:cTn>
+                              </p:par>
+                              <p:par>
+                                <p:cTn id="30" presetID="1" presetClass="entr" presetSubtype="0" fill="hold" grpId="0" nodeType="withEffect">
+                                  <p:stCondLst>
+                                    <p:cond delay="0"/>
+                                  </p:stCondLst>
+                                  <p:childTnLst>
+                                    <p:set>
+                                      <p:cBhvr>
+                                        <p:cTn id="29" dur="1" fill="hold">
+                                          <p:stCondLst>
+                                            <p:cond delay="0"/>
+                                          </p:stCondLst>
+                                        </p:cTn>
+                                        <p:tgtEl>
+                                          <p:spTgt spid="22"/>
+                                        </p:tgtEl>
+                                        <p:attrNameLst>
+                                          <p:attrName>style.visibility</p:attrName>
+                                        </p:attrNameLst>
+                                      </p:cBhvr>
+                                      <p:to>
+                                        <p:strVal val="visible"/>
+                                      </p:to>
+                                    </p:set>
+                                  </p:childTnLst>
+                                </p:cTn>
+                              </p:par>
+                              <p:par>
+                                <p:cTn id="32" presetID="1" presetClass="entr" presetSubtype="0" fill="hold" grpId="0" nodeType="withEffect">
+                                  <p:stCondLst>
+                                    <p:cond delay="0"/>
+                                  </p:stCondLst>
+                                  <p:childTnLst>
+                                    <p:set>
+                                      <p:cBhvr>
+                                        <p:cTn id="31" dur="1" fill="hold">
+                                          <p:stCondLst>
+                                            <p:cond delay="0"/>
+                                          </p:stCondLst>
+                                        </p:cTn>
+                                        <p:tgtEl>
+                                          <p:spTgt spid="23"/>
+                                        </p:tgtEl>
+                                        <p:attrNameLst>
+                                          <p:attrName>style.visibility</p:attrName>
+                                        </p:attrNameLst>
+                                      </p:cBhvr>
+                                      <p:to>
+                                        <p:strVal val="visible"/>
+                                      </p:to>
+                                    </p:set>
+                                  </p:childTnLst>
+                                </p:cTn>
+                              </p:par>
+                            </p:childTnLst>
+                          </p:cTn>
+                        </p:par>
+                      </p:childTnLst>
+                    </p:cTn>
+                  </p:par>
+                  <p:par>
+                    <p:cTn id="33" fill="hold">
+                      <p:stCondLst>
+                        <p:cond delay="indefinite"/>
+                      </p:stCondLst>
+                      <p:childTnLst>
+                        <p:par>
+                          <p:cTn id="34" fill="hold">
+                            <p:stCondLst>
+                              <p:cond delay="0"/>
+                            </p:stCondLst>
+                            <p:childTnLst>
+                              <p:par>
+                                <p:cTn id="36" presetID="1" presetClass="entr" presetSubtype="0" fill="hold" grpId="0" nodeType="clickEffect">
+                                  <p:stCondLst>
+                                    <p:cond delay="0"/>
+                                  </p:stCondLst>
+                                  <p:childTnLst>
+                                    <p:set>
+                                      <p:cBhvr>
+                                        <p:cTn id="35" dur="1" fill="hold">
+                                          <p:stCondLst>
+                                            <p:cond delay="0"/>
+                                          </p:stCondLst>
+                                        </p:cTn>
+                                        <p:tgtEl>
+                                          <p:spTgt spid="24"/>
+                                        </p:tgtEl>
+                                        <p:attrNameLst>
+                                          <p:attrName>style.visibility</p:attrName>
+                                        </p:attrNameLst>
+                                      </p:cBhvr>
+                                      <p:to>
+                                        <p:strVal val="visible"/>
+                                      </p:to>
+                                    </p:set>
+                                  </p:childTnLst>
+                                </p:cTn>
+                              </p:par>
+                              <p:par>
+                                <p:cTn id="38" presetID="1" presetClass="entr" presetSubtype="0" fill="hold" grpId="0" nodeType="withEffect">
+                                  <p:stCondLst>
+                                    <p:cond delay="0"/>
+                                  </p:stCondLst>
+                                  <p:childTnLst>
+                                    <p:set>
+                                      <p:cBhvr>
+                                        <p:cTn id="37" dur="1" fill="hold">
+                                          <p:stCondLst>
+                                            <p:cond delay="0"/>
+                                          </p:stCondLst>
+                                        </p:cTn>
+                                        <p:tgtEl>
+                                          <p:spTgt spid="25"/>
+                                        </p:tgtEl>
+                                        <p:attrNameLst>
+                                          <p:attrName>style.visibility</p:attrName>
+                                        </p:attrNameLst>
+                                      </p:cBhvr>
+                                      <p:to>
+                                        <p:strVal val="visible"/>
+                                      </p:to>
+                                    </p:set>
+                                  </p:childTnLst>
+                                </p:cTn>
+                              </p:par>
+                              <p:par>
+                                <p:cTn id="40" presetID="1" presetClass="entr" presetSubtype="0" fill="hold" nodeType="withEffect">
+                                  <p:stCondLst>
+                                    <p:cond delay="0"/>
+                                  </p:stCondLst>
+                                  <p:childTnLst>
+                                    <p:set>
+                                      <p:cBhvr>
+                                        <p:cTn id="39" dur="1" fill="hold">
+                                          <p:stCondLst>
+                                            <p:cond delay="0"/>
+                                          </p:stCondLst>
+                                        </p:cTn>
+                                        <p:tgtEl>
+                                          <p:spTgt spid="26"/>
+                                        </p:tgtEl>
+                                        <p:attrNameLst>
+                                          <p:attrName>style.visibility</p:attrName>
+                                        </p:attrNameLst>
+                                      </p:cBhvr>
+                                      <p:to>
+                                        <p:strVal val="visible"/>
+                                      </p:to>
+                                    </p:set>
+                                  </p:childTnLst>
+                                </p:cTn>
+                              </p:par>
+                              <p:par>
+                                <p:cTn id="42" presetID="1" presetClass="entr" presetSubtype="0" fill="hold" grpId="0" nodeType="withEffect">
+                                  <p:stCondLst>
+                                    <p:cond delay="0"/>
+                                  </p:stCondLst>
+                                  <p:childTnLst>
+                                    <p:set>
+                                      <p:cBhvr>
+                                        <p:cTn id="41" dur="1" fill="hold">
+                                          <p:stCondLst>
+                                            <p:cond delay="0"/>
+                                          </p:stCondLst>
+                                        </p:cTn>
+                                        <p:tgtEl>
+                                          <p:spTgt spid="27"/>
+                                        </p:tgtEl>
+                                        <p:attrNameLst>
+                                          <p:attrName>style.visibility</p:attrName>
+                                        </p:attrNameLst>
+                                      </p:cBhvr>
+                                      <p:to>
+                                        <p:strVal val="visible"/>
+                                      </p:to>
+                                    </p:set>
+                                  </p:childTnLst>
+                                </p:cTn>
+                              </p:par>
+                            </p:childTnLst>
+                          </p:cTn>
+                        </p:par>
+                      </p:childTnLst>
+                    </p:cTn>
+                  </p:par>
+                </p:childTnLst>
+              </p:cTn>
+              <p:prevCondLst>
+                <p:cond evt="onPrev" delay="0">
+                  <p:tgtEl>
+                    <p:sldTgt/>
+                  </p:tgtEl>
+                </p:cond>
+              </p:prevCondLst>
+              <p:nextCondLst>
+                <p:cond evt="onNext" delay="0">
+                  <p:tgtEl>
+                    <p:sldTgt/>
+                  </p:tgtEl>
+                </p:cond>
+              </p:nextCondLst>
+            </p:seq>
+          </p:childTnLst>
+        </p:cTn>
+      </p:par>
+    </p:tnLst>
+    <p:bldLst>
+      <p:bldP spid="8" grpId="0" animBg="1"/>
+      <p:bldP spid="10" grpId="0" animBg="1"/>
+      <p:bldP spid="11" grpId="0" animBg="1"/>
+      <p:bldP spid="14" grpId="0" animBg="1"/>
+      <p:bldP spid="16" grpId="0" animBg="1"/>
+      <p:bldP spid="17" grpId="0" animBg="1"/>
+      <p:bldP spid="20" grpId="0" animBg="1"/>
+      <p:bldP spid="22" grpId="0" animBg="1"/>
+      <p:bldP spid="23" grpId="0" animBg="1"/>
+      <p:bldP spid="24" grpId="0" animBg="1"/>
+      <p:bldP spid="25" grpId="0" animBg="1"/>
+      <p:bldP spid="27" grpId="0" animBg="1"/>
+    </p:bldLst>
+  </p:timing>
 </p:sld>
 </file>
 
@@ -7249,7 +8111,7 @@
       </p:sp>
       <p:sp>
         <p:nvSpPr>
-          <p:cNvPr id="12" name="Shape 10"/>
+          <p:cNvPr id="12" name="click-1"/>
           <p:cNvSpPr/>
           <p:nvPr/>
         </p:nvSpPr>
@@ -7278,7 +8140,7 @@
       </p:sp>
       <p:sp>
         <p:nvSpPr>
-          <p:cNvPr id="13" name="Shape 11"/>
+          <p:cNvPr id="13" name="click-1"/>
           <p:cNvSpPr/>
           <p:nvPr/>
         </p:nvSpPr>
@@ -7298,7 +8160,7 @@
       </p:sp>
       <p:pic>
         <p:nvPicPr>
-          <p:cNvPr id="14" name="Image 0" descr="preencoded.png">    </p:cNvPr>
+          <p:cNvPr id="14" name="click-1" descr="preencoded.png">    </p:cNvPr>
           <p:cNvPicPr>
             <a:picLocks noChangeAspect="1"/>
           </p:cNvPicPr>
@@ -7322,7 +8184,7 @@
       </p:pic>
       <p:sp>
         <p:nvSpPr>
-          <p:cNvPr id="15" name="Text 12"/>
+          <p:cNvPr id="15" name="click-1"/>
           <p:cNvSpPr/>
           <p:nvPr/>
         </p:nvSpPr>
@@ -7462,6 +8324,167 @@
   <p:clrMapOvr>
     <a:masterClrMapping/>
   </p:clrMapOvr>
+  <p:timing>
+    <p:tnLst>
+      <p:par>
+        <p:cTn id="1" dur="indefinite" restart="never" nodeType="tmRoot">
+          <p:childTnLst>
+            <p:seq concurrent="1" nextAc="seek">
+              <p:cTn id="2" dur="indefinite" nodeType="mainSeq">
+                <p:childTnLst>
+                  <p:par>
+                    <p:cTn id="3" fill="hold">
+                      <p:stCondLst>
+                        <p:cond delay="indefinite"/>
+                      </p:stCondLst>
+                      <p:childTnLst>
+                        <p:par>
+                          <p:cTn id="4" fill="hold">
+                            <p:stCondLst>
+                              <p:cond delay="0"/>
+                            </p:stCondLst>
+                            <p:childTnLst>
+                              <p:par>
+                                <p:cTn id="6" presetID="1" presetClass="entr" presetSubtype="0" fill="hold" grpId="0" nodeType="clickEffect">
+                                  <p:stCondLst>
+                                    <p:cond delay="0"/>
+                                  </p:stCondLst>
+                                  <p:childTnLst>
+                                    <p:set>
+                                      <p:cBhvr>
+                                        <p:cTn id="5" dur="1" fill="hold">
+                                          <p:stCondLst>
+                                            <p:cond delay="0"/>
+                                          </p:stCondLst>
+                                        </p:cTn>
+                                        <p:tgtEl>
+                                          <p:spTgt spid="12"/>
+                                        </p:tgtEl>
+                                        <p:attrNameLst>
+                                          <p:attrName>style.visibility</p:attrName>
+                                        </p:attrNameLst>
+                                      </p:cBhvr>
+                                      <p:to>
+                                        <p:strVal val="visible"/>
+                                      </p:to>
+                                    </p:set>
+                                  </p:childTnLst>
+                                </p:cTn>
+                              </p:par>
+                              <p:par>
+                                <p:cTn id="8" presetID="1" presetClass="entr" presetSubtype="0" fill="hold" grpId="0" nodeType="withEffect">
+                                  <p:stCondLst>
+                                    <p:cond delay="0"/>
+                                  </p:stCondLst>
+                                  <p:childTnLst>
+                                    <p:set>
+                                      <p:cBhvr>
+                                        <p:cTn id="7" dur="1" fill="hold">
+                                          <p:stCondLst>
+                                            <p:cond delay="0"/>
+                                          </p:stCondLst>
+                                        </p:cTn>
+                                        <p:tgtEl>
+                                          <p:spTgt spid="13"/>
+                                        </p:tgtEl>
+                                        <p:attrNameLst>
+                                          <p:attrName>style.visibility</p:attrName>
+                                        </p:attrNameLst>
+                                      </p:cBhvr>
+                                      <p:to>
+                                        <p:strVal val="visible"/>
+                                      </p:to>
+                                    </p:set>
+                                  </p:childTnLst>
+                                </p:cTn>
+                              </p:par>
+                              <p:par>
+                                <p:cTn id="10" presetID="1" presetClass="entr" presetSubtype="0" fill="hold" nodeType="withEffect">
+                                  <p:stCondLst>
+                                    <p:cond delay="0"/>
+                                  </p:stCondLst>
+                                  <p:childTnLst>
+                                    <p:set>
+                                      <p:cBhvr>
+                                        <p:cTn id="9" dur="1" fill="hold">
+                                          <p:stCondLst>
+                                            <p:cond delay="0"/>
+                                          </p:stCondLst>
+                                        </p:cTn>
+                                        <p:tgtEl>
+                                          <p:spTgt spid="14"/>
+                                        </p:tgtEl>
+                                        <p:attrNameLst>
+                                          <p:attrName>style.visibility</p:attrName>
+                                        </p:attrNameLst>
+                                      </p:cBhvr>
+                                      <p:to>
+                                        <p:strVal val="visible"/>
+                                      </p:to>
+                                    </p:set>
+                                  </p:childTnLst>
+                                </p:cTn>
+                              </p:par>
+                              <p:par>
+                                <p:cTn id="12" presetID="1" presetClass="entr" presetSubtype="0" fill="hold" grpId="0" nodeType="withEffect">
+                                  <p:stCondLst>
+                                    <p:cond delay="0"/>
+                                  </p:stCondLst>
+                                  <p:childTnLst>
+                                    <p:set>
+                                      <p:cBhvr>
+                                        <p:cTn id="11" dur="1" fill="hold">
+                                          <p:stCondLst>
+                                            <p:cond delay="0"/>
+                                          </p:stCondLst>
+                                        </p:cTn>
+                                        <p:tgtEl>
+                                          <p:spTgt spid="15"/>
+                                        </p:tgtEl>
+                                        <p:attrNameLst>
+                                          <p:attrName>style.visibility</p:attrName>
+                                        </p:attrNameLst>
+                                      </p:cBhvr>
+                                      <p:to>
+                                        <p:strVal val="visible"/>
+                                      </p:to>
+                                    </p:set>
+                                  </p:childTnLst>
+                                </p:cTn>
+                              </p:par>
+                            </p:childTnLst>
+                          </p:cTn>
+                        </p:par>
+                      </p:childTnLst>
+                    </p:cTn>
+                  </p:par>
+                </p:childTnLst>
+              </p:cTn>
+              <p:prevCondLst>
+                <p:cond evt="onPrev" delay="0">
+                  <p:tgtEl>
+                    <p:sldTgt/>
+                  </p:tgtEl>
+                </p:cond>
+              </p:prevCondLst>
+              <p:nextCondLst>
+                <p:cond evt="onNext" delay="0">
+                  <p:tgtEl>
+                    <p:sldTgt/>
+                  </p:tgtEl>
+                </p:cond>
+              </p:nextCondLst>
+            </p:seq>
+          </p:childTnLst>
+        </p:cTn>
+      </p:par>
+    </p:tnLst>
+    <p:bldLst>
+      <p:bldP spid="12" grpId="0" animBg="1"/>
+      <p:bldP spid="13" grpId="0" animBg="1"/>
+      <p:bldP spid="15" grpId="0" animBg="1"/>
+    </p:bldLst>
+  </p:timing>
 </p:sld>
 </file>
 
@@ -8526,7 +9549,7 @@
       </p:sp>
       <p:sp>
         <p:nvSpPr>
-          <p:cNvPr id="12" name="Shape 10"/>
+          <p:cNvPr id="12" name="click-1"/>
           <p:cNvSpPr/>
           <p:nvPr/>
         </p:nvSpPr>
@@ -8555,7 +9578,7 @@
       </p:sp>
       <p:sp>
         <p:nvSpPr>
-          <p:cNvPr id="13" name="Text 11"/>
+          <p:cNvPr id="13" name="click-1"/>
           <p:cNvSpPr/>
           <p:nvPr/>
         </p:nvSpPr>
@@ -8695,6 +9718,112 @@
   <p:clrMapOvr>
     <a:masterClrMapping/>
   </p:clrMapOvr>
+  <p:timing>
+    <p:tnLst>
+      <p:par>
+        <p:cTn id="1" dur="indefinite" restart="never" nodeType="tmRoot">
+          <p:childTnLst>
+            <p:seq concurrent="1" nextAc="seek">
+              <p:cTn id="2" dur="indefinite" nodeType="mainSeq">
+                <p:childTnLst>
+                  <p:par>
+                    <p:cTn id="3" fill="hold">
+                      <p:stCondLst>
+                        <p:cond delay="indefinite"/>
+                      </p:stCondLst>
+                      <p:childTnLst>
+                        <p:par>
+                          <p:cTn id="4" fill="hold">
+                            <p:stCondLst>
+                              <p:cond delay="0"/>
+                            </p:stCondLst>
+                            <p:childTnLst>
+                              <p:par>
+                                <p:cTn id="6" presetID="1" presetClass="entr" presetSubtype="0" fill="hold" grpId="0" nodeType="clickEffect">
+                                  <p:stCondLst>
+                                    <p:cond delay="0"/>
+                                  </p:stCondLst>
+                                  <p:childTnLst>
+                                    <p:set>
+                                      <p:cBhvr>
+                                        <p:cTn id="5" dur="1" fill="hold">
+                                          <p:stCondLst>
+                                            <p:cond delay="0"/>
+                                          </p:stCondLst>
+                                        </p:cTn>
+                                        <p:tgtEl>
+                                          <p:spTgt spid="12"/>
+                                        </p:tgtEl>
+                                        <p:attrNameLst>
+                                          <p:attrName>style.visibility</p:attrName>
+                                        </p:attrNameLst>
+                                      </p:cBhvr>
+                                      <p:to>
+                                        <p:strVal val="visible"/>
+                                      </p:to>
+                                    </p:set>
+                                  </p:childTnLst>
+                                </p:cTn>
+                              </p:par>
+                              <p:par>
+                                <p:cTn id="8" presetID="1" presetClass="entr" presetSubtype="0" fill="hold" grpId="0" nodeType="withEffect">
+                                  <p:stCondLst>
+                                    <p:cond delay="0"/>
+                                  </p:stCondLst>
+                                  <p:childTnLst>
+                                    <p:set>
+                                      <p:cBhvr>
+                                        <p:cTn id="7" dur="1" fill="hold">
+                                          <p:stCondLst>
+                                            <p:cond delay="0"/>
+                                          </p:stCondLst>
+                                        </p:cTn>
+                                        <p:tgtEl>
+                                          <p:spTgt spid="13"/>
+                                        </p:tgtEl>
+                                        <p:attrNameLst>
+                                          <p:attrName>style.visibility</p:attrName>
+                                        </p:attrNameLst>
+                                      </p:cBhvr>
+                                      <p:to>
+                                        <p:strVal val="visible"/>
+                                      </p:to>
+                                    </p:set>
+                                  </p:childTnLst>
+                                </p:cTn>
+                              </p:par>
+                            </p:childTnLst>
+                          </p:cTn>
+                        </p:par>
+                      </p:childTnLst>
+                    </p:cTn>
+                  </p:par>
+                </p:childTnLst>
+              </p:cTn>
+              <p:prevCondLst>
+                <p:cond evt="onPrev" delay="0">
+                  <p:tgtEl>
+                    <p:sldTgt/>
+                  </p:tgtEl>
+                </p:cond>
+              </p:prevCondLst>
+              <p:nextCondLst>
+                <p:cond evt="onNext" delay="0">
+                  <p:tgtEl>
+                    <p:sldTgt/>
+                  </p:tgtEl>
+                </p:cond>
+              </p:nextCondLst>
+            </p:seq>
+          </p:childTnLst>
+        </p:cTn>
+      </p:par>
+    </p:tnLst>
+    <p:bldLst>
+      <p:bldP spid="12" grpId="0" animBg="1"/>
+      <p:bldP spid="13" grpId="0" animBg="1"/>
+    </p:bldLst>
+  </p:timing>
 </p:sld>
 </file>
 
@@ -9759,7 +10888,7 @@
       </p:sp>
       <p:sp>
         <p:nvSpPr>
-          <p:cNvPr id="12" name="Shape 10"/>
+          <p:cNvPr id="12" name="click-1"/>
           <p:cNvSpPr/>
           <p:nvPr/>
         </p:nvSpPr>
@@ -9788,7 +10917,7 @@
       </p:sp>
       <p:sp>
         <p:nvSpPr>
-          <p:cNvPr id="13" name="Text 11"/>
+          <p:cNvPr id="13" name="click-1"/>
           <p:cNvSpPr/>
           <p:nvPr/>
         </p:nvSpPr>
@@ -9928,6 +11057,112 @@
   <p:clrMapOvr>
     <a:masterClrMapping/>
   </p:clrMapOvr>
+  <p:timing>
+    <p:tnLst>
+      <p:par>
+        <p:cTn id="1" dur="indefinite" restart="never" nodeType="tmRoot">
+          <p:childTnLst>
+            <p:seq concurrent="1" nextAc="seek">
+              <p:cTn id="2" dur="indefinite" nodeType="mainSeq">
+                <p:childTnLst>
+                  <p:par>
+                    <p:cTn id="3" fill="hold">
+                      <p:stCondLst>
+                        <p:cond delay="indefinite"/>
+                      </p:stCondLst>
+                      <p:childTnLst>
+                        <p:par>
+                          <p:cTn id="4" fill="hold">
+                            <p:stCondLst>
+                              <p:cond delay="0"/>
+                            </p:stCondLst>
+                            <p:childTnLst>
+                              <p:par>
+                                <p:cTn id="6" presetID="1" presetClass="entr" presetSubtype="0" fill="hold" grpId="0" nodeType="clickEffect">
+                                  <p:stCondLst>
+                                    <p:cond delay="0"/>
+                                  </p:stCondLst>
+                                  <p:childTnLst>
+                                    <p:set>
+                                      <p:cBhvr>
+                                        <p:cTn id="5" dur="1" fill="hold">
+                                          <p:stCondLst>
+                                            <p:cond delay="0"/>
+                                          </p:stCondLst>
+                                        </p:cTn>
+                                        <p:tgtEl>
+                                          <p:spTgt spid="12"/>
+                                        </p:tgtEl>
+                                        <p:attrNameLst>
+                                          <p:attrName>style.visibility</p:attrName>
+                                        </p:attrNameLst>
+                                      </p:cBhvr>
+                                      <p:to>
+                                        <p:strVal val="visible"/>
+                                      </p:to>
+                                    </p:set>
+                                  </p:childTnLst>
+                                </p:cTn>
+                              </p:par>
+                              <p:par>
+                                <p:cTn id="8" presetID="1" presetClass="entr" presetSubtype="0" fill="hold" grpId="0" nodeType="withEffect">
+                                  <p:stCondLst>
+                                    <p:cond delay="0"/>
+                                  </p:stCondLst>
+                                  <p:childTnLst>
+                                    <p:set>
+                                      <p:cBhvr>
+                                        <p:cTn id="7" dur="1" fill="hold">
+                                          <p:stCondLst>
+                                            <p:cond delay="0"/>
+                                          </p:stCondLst>
+                                        </p:cTn>
+                                        <p:tgtEl>
+                                          <p:spTgt spid="13"/>
+                                        </p:tgtEl>
+                                        <p:attrNameLst>
+                                          <p:attrName>style.visibility</p:attrName>
+                                        </p:attrNameLst>
+                                      </p:cBhvr>
+                                      <p:to>
+                                        <p:strVal val="visible"/>
+                                      </p:to>
+                                    </p:set>
+                                  </p:childTnLst>
+                                </p:cTn>
+                              </p:par>
+                            </p:childTnLst>
+                          </p:cTn>
+                        </p:par>
+                      </p:childTnLst>
+                    </p:cTn>
+                  </p:par>
+                </p:childTnLst>
+              </p:cTn>
+              <p:prevCondLst>
+                <p:cond evt="onPrev" delay="0">
+                  <p:tgtEl>
+                    <p:sldTgt/>
+                  </p:tgtEl>
+                </p:cond>
+              </p:prevCondLst>
+              <p:nextCondLst>
+                <p:cond evt="onNext" delay="0">
+                  <p:tgtEl>
+                    <p:sldTgt/>
+                  </p:tgtEl>
+                </p:cond>
+              </p:nextCondLst>
+            </p:seq>
+          </p:childTnLst>
+        </p:cTn>
+      </p:par>
+    </p:tnLst>
+    <p:bldLst>
+      <p:bldP spid="12" grpId="0" animBg="1"/>
+      <p:bldP spid="13" grpId="0" animBg="1"/>
+    </p:bldLst>
+  </p:timing>
 </p:sld>
 </file>
 
@@ -11495,7 +12730,7 @@
       </p:sp>
       <p:sp>
         <p:nvSpPr>
-          <p:cNvPr id="12" name="Shape 10"/>
+          <p:cNvPr id="12" name="click-1"/>
           <p:cNvSpPr/>
           <p:nvPr/>
         </p:nvSpPr>
@@ -11524,7 +12759,7 @@
       </p:sp>
       <p:sp>
         <p:nvSpPr>
-          <p:cNvPr id="13" name="Text 11"/>
+          <p:cNvPr id="13" name="click-1"/>
           <p:cNvSpPr/>
           <p:nvPr/>
         </p:nvSpPr>
@@ -11664,6 +12899,112 @@
   <p:clrMapOvr>
     <a:masterClrMapping/>
   </p:clrMapOvr>
+  <p:timing>
+    <p:tnLst>
+      <p:par>
+        <p:cTn id="1" dur="indefinite" restart="never" nodeType="tmRoot">
+          <p:childTnLst>
+            <p:seq concurrent="1" nextAc="seek">
+              <p:cTn id="2" dur="indefinite" nodeType="mainSeq">
+                <p:childTnLst>
+                  <p:par>
+                    <p:cTn id="3" fill="hold">
+                      <p:stCondLst>
+                        <p:cond delay="indefinite"/>
+                      </p:stCondLst>
+                      <p:childTnLst>
+                        <p:par>
+                          <p:cTn id="4" fill="hold">
+                            <p:stCondLst>
+                              <p:cond delay="0"/>
+                            </p:stCondLst>
+                            <p:childTnLst>
+                              <p:par>
+                                <p:cTn id="6" presetID="1" presetClass="entr" presetSubtype="0" fill="hold" grpId="0" nodeType="clickEffect">
+                                  <p:stCondLst>
+                                    <p:cond delay="0"/>
+                                  </p:stCondLst>
+                                  <p:childTnLst>
+                                    <p:set>
+                                      <p:cBhvr>
+                                        <p:cTn id="5" dur="1" fill="hold">
+                                          <p:stCondLst>
+                                            <p:cond delay="0"/>
+                                          </p:stCondLst>
+                                        </p:cTn>
+                                        <p:tgtEl>
+                                          <p:spTgt spid="12"/>
+                                        </p:tgtEl>
+                                        <p:attrNameLst>
+                                          <p:attrName>style.visibility</p:attrName>
+                                        </p:attrNameLst>
+                                      </p:cBhvr>
+                                      <p:to>
+                                        <p:strVal val="visible"/>
+                                      </p:to>
+                                    </p:set>
+                                  </p:childTnLst>
+                                </p:cTn>
+                              </p:par>
+                              <p:par>
+                                <p:cTn id="8" presetID="1" presetClass="entr" presetSubtype="0" fill="hold" grpId="0" nodeType="withEffect">
+                                  <p:stCondLst>
+                                    <p:cond delay="0"/>
+                                  </p:stCondLst>
+                                  <p:childTnLst>
+                                    <p:set>
+                                      <p:cBhvr>
+                                        <p:cTn id="7" dur="1" fill="hold">
+                                          <p:stCondLst>
+                                            <p:cond delay="0"/>
+                                          </p:stCondLst>
+                                        </p:cTn>
+                                        <p:tgtEl>
+                                          <p:spTgt spid="13"/>
+                                        </p:tgtEl>
+                                        <p:attrNameLst>
+                                          <p:attrName>style.visibility</p:attrName>
+                                        </p:attrNameLst>
+                                      </p:cBhvr>
+                                      <p:to>
+                                        <p:strVal val="visible"/>
+                                      </p:to>
+                                    </p:set>
+                                  </p:childTnLst>
+                                </p:cTn>
+                              </p:par>
+                            </p:childTnLst>
+                          </p:cTn>
+                        </p:par>
+                      </p:childTnLst>
+                    </p:cTn>
+                  </p:par>
+                </p:childTnLst>
+              </p:cTn>
+              <p:prevCondLst>
+                <p:cond evt="onPrev" delay="0">
+                  <p:tgtEl>
+                    <p:sldTgt/>
+                  </p:tgtEl>
+                </p:cond>
+              </p:prevCondLst>
+              <p:nextCondLst>
+                <p:cond evt="onNext" delay="0">
+                  <p:tgtEl>
+                    <p:sldTgt/>
+                  </p:tgtEl>
+                </p:cond>
+              </p:nextCondLst>
+            </p:seq>
+          </p:childTnLst>
+        </p:cTn>
+      </p:par>
+    </p:tnLst>
+    <p:bldLst>
+      <p:bldP spid="12" grpId="0" animBg="1"/>
+      <p:bldP spid="13" grpId="0" animBg="1"/>
+    </p:bldLst>
+  </p:timing>
 </p:sld>
 </file>
 
@@ -18678,7 +20019,7 @@
                 <a:ea typeface="Cambria" pitchFamily="34" charset="-122"/>
                 <a:cs typeface="Cambria" pitchFamily="34" charset="-120"/>
               </a:rPr>
-              <a:t>10 hrs/week × 14 weeks = 140 hours</a:t>
+              <a:t>10 hrs/week × 10 weeks left = 100 hours</a:t>
             </a:r>
             <a:endParaRPr lang="en-US" sz="2000" dirty="0"/>
           </a:p>
@@ -18728,7 +20069,7 @@
       </p:sp>
       <p:sp>
         <p:nvSpPr>
-          <p:cNvPr id="11" name="Shape 8"/>
+          <p:cNvPr id="11" name="click-1"/>
           <p:cNvSpPr/>
           <p:nvPr/>
         </p:nvSpPr>
@@ -18757,7 +20098,7 @@
       </p:sp>
       <p:sp>
         <p:nvSpPr>
-          <p:cNvPr id="12" name="Shape 9"/>
+          <p:cNvPr id="12" name="click-1"/>
           <p:cNvSpPr/>
           <p:nvPr/>
         </p:nvSpPr>
@@ -18777,7 +20118,7 @@
       </p:sp>
       <p:pic>
         <p:nvPicPr>
-          <p:cNvPr id="13" name="Image 1" descr="preencoded.png">    </p:cNvPr>
+          <p:cNvPr id="13" name="click-1" descr="preencoded.png">    </p:cNvPr>
           <p:cNvPicPr>
             <a:picLocks noChangeAspect="1"/>
           </p:cNvPicPr>
@@ -18801,7 +20142,7 @@
       </p:pic>
       <p:sp>
         <p:nvSpPr>
-          <p:cNvPr id="14" name="Text 10"/>
+          <p:cNvPr id="14" name="click-1"/>
           <p:cNvSpPr/>
           <p:nvPr/>
         </p:nvSpPr>
@@ -18840,7 +20181,7 @@
       </p:sp>
       <p:sp>
         <p:nvSpPr>
-          <p:cNvPr id="15" name="Text 11"/>
+          <p:cNvPr id="15" name="click-1"/>
           <p:cNvSpPr/>
           <p:nvPr/>
         </p:nvSpPr>
@@ -18879,7 +20220,7 @@
       </p:sp>
       <p:sp>
         <p:nvSpPr>
-          <p:cNvPr id="16" name="Text 12"/>
+          <p:cNvPr id="16" name="click-1"/>
           <p:cNvSpPr/>
           <p:nvPr/>
         </p:nvSpPr>
@@ -18921,7 +20262,7 @@
       </p:sp>
       <p:sp>
         <p:nvSpPr>
-          <p:cNvPr id="17" name="Shape 13"/>
+          <p:cNvPr id="17" name="click-2"/>
           <p:cNvSpPr/>
           <p:nvPr/>
         </p:nvSpPr>
@@ -18950,7 +20291,7 @@
       </p:sp>
       <p:sp>
         <p:nvSpPr>
-          <p:cNvPr id="18" name="Shape 14"/>
+          <p:cNvPr id="18" name="click-2"/>
           <p:cNvSpPr/>
           <p:nvPr/>
         </p:nvSpPr>
@@ -18970,7 +20311,7 @@
       </p:sp>
       <p:pic>
         <p:nvPicPr>
-          <p:cNvPr id="19" name="Image 2" descr="preencoded.png">    </p:cNvPr>
+          <p:cNvPr id="19" name="click-2" descr="preencoded.png">    </p:cNvPr>
           <p:cNvPicPr>
             <a:picLocks noChangeAspect="1"/>
           </p:cNvPicPr>
@@ -18994,7 +20335,7 @@
       </p:pic>
       <p:sp>
         <p:nvSpPr>
-          <p:cNvPr id="20" name="Text 15"/>
+          <p:cNvPr id="20" name="click-2"/>
           <p:cNvSpPr/>
           <p:nvPr/>
         </p:nvSpPr>
@@ -19033,7 +20374,7 @@
       </p:sp>
       <p:sp>
         <p:nvSpPr>
-          <p:cNvPr id="21" name="Text 16"/>
+          <p:cNvPr id="21" name="click-2"/>
           <p:cNvSpPr/>
           <p:nvPr/>
         </p:nvSpPr>
@@ -19075,7 +20416,7 @@
       </p:sp>
       <p:sp>
         <p:nvSpPr>
-          <p:cNvPr id="22" name="Shape 17"/>
+          <p:cNvPr id="22" name="click-3"/>
           <p:cNvSpPr/>
           <p:nvPr/>
         </p:nvSpPr>
@@ -19104,7 +20445,7 @@
       </p:sp>
       <p:sp>
         <p:nvSpPr>
-          <p:cNvPr id="23" name="Text 18"/>
+          <p:cNvPr id="23" name="click-3"/>
           <p:cNvSpPr/>
           <p:nvPr/>
         </p:nvSpPr>
@@ -19238,6 +20579,454 @@
   <p:clrMapOvr>
     <a:masterClrMapping/>
   </p:clrMapOvr>
+  <p:timing>
+    <p:tnLst>
+      <p:par>
+        <p:cTn id="1" dur="indefinite" restart="never" nodeType="tmRoot">
+          <p:childTnLst>
+            <p:seq concurrent="1" nextAc="seek">
+              <p:cTn id="2" dur="indefinite" nodeType="mainSeq">
+                <p:childTnLst>
+                  <p:par>
+                    <p:cTn id="3" fill="hold">
+                      <p:stCondLst>
+                        <p:cond delay="indefinite"/>
+                      </p:stCondLst>
+                      <p:childTnLst>
+                        <p:par>
+                          <p:cTn id="4" fill="hold">
+                            <p:stCondLst>
+                              <p:cond delay="0"/>
+                            </p:stCondLst>
+                            <p:childTnLst>
+                              <p:par>
+                                <p:cTn id="6" presetID="1" presetClass="entr" presetSubtype="0" fill="hold" grpId="0" nodeType="clickEffect">
+                                  <p:stCondLst>
+                                    <p:cond delay="0"/>
+                                  </p:stCondLst>
+                                  <p:childTnLst>
+                                    <p:set>
+                                      <p:cBhvr>
+                                        <p:cTn id="5" dur="1" fill="hold">
+                                          <p:stCondLst>
+                                            <p:cond delay="0"/>
+                                          </p:stCondLst>
+                                        </p:cTn>
+                                        <p:tgtEl>
+                                          <p:spTgt spid="11"/>
+                                        </p:tgtEl>
+                                        <p:attrNameLst>
+                                          <p:attrName>style.visibility</p:attrName>
+                                        </p:attrNameLst>
+                                      </p:cBhvr>
+                                      <p:to>
+                                        <p:strVal val="visible"/>
+                                      </p:to>
+                                    </p:set>
+                                  </p:childTnLst>
+                                </p:cTn>
+                              </p:par>
+                              <p:par>
+                                <p:cTn id="8" presetID="1" presetClass="entr" presetSubtype="0" fill="hold" grpId="0" nodeType="withEffect">
+                                  <p:stCondLst>
+                                    <p:cond delay="0"/>
+                                  </p:stCondLst>
+                                  <p:childTnLst>
+                                    <p:set>
+                                      <p:cBhvr>
+                                        <p:cTn id="7" dur="1" fill="hold">
+                                          <p:stCondLst>
+                                            <p:cond delay="0"/>
+                                          </p:stCondLst>
+                                        </p:cTn>
+                                        <p:tgtEl>
+                                          <p:spTgt spid="12"/>
+                                        </p:tgtEl>
+                                        <p:attrNameLst>
+                                          <p:attrName>style.visibility</p:attrName>
+                                        </p:attrNameLst>
+                                      </p:cBhvr>
+                                      <p:to>
+                                        <p:strVal val="visible"/>
+                                      </p:to>
+                                    </p:set>
+                                  </p:childTnLst>
+                                </p:cTn>
+                              </p:par>
+                              <p:par>
+                                <p:cTn id="10" presetID="1" presetClass="entr" presetSubtype="0" fill="hold" nodeType="withEffect">
+                                  <p:stCondLst>
+                                    <p:cond delay="0"/>
+                                  </p:stCondLst>
+                                  <p:childTnLst>
+                                    <p:set>
+                                      <p:cBhvr>
+                                        <p:cTn id="9" dur="1" fill="hold">
+                                          <p:stCondLst>
+                                            <p:cond delay="0"/>
+                                          </p:stCondLst>
+                                        </p:cTn>
+                                        <p:tgtEl>
+                                          <p:spTgt spid="13"/>
+                                        </p:tgtEl>
+                                        <p:attrNameLst>
+                                          <p:attrName>style.visibility</p:attrName>
+                                        </p:attrNameLst>
+                                      </p:cBhvr>
+                                      <p:to>
+                                        <p:strVal val="visible"/>
+                                      </p:to>
+                                    </p:set>
+                                  </p:childTnLst>
+                                </p:cTn>
+                              </p:par>
+                              <p:par>
+                                <p:cTn id="12" presetID="1" presetClass="entr" presetSubtype="0" fill="hold" grpId="0" nodeType="withEffect">
+                                  <p:stCondLst>
+                                    <p:cond delay="0"/>
+                                  </p:stCondLst>
+                                  <p:childTnLst>
+                                    <p:set>
+                                      <p:cBhvr>
+                                        <p:cTn id="11" dur="1" fill="hold">
+                                          <p:stCondLst>
+                                            <p:cond delay="0"/>
+                                          </p:stCondLst>
+                                        </p:cTn>
+                                        <p:tgtEl>
+                                          <p:spTgt spid="14"/>
+                                        </p:tgtEl>
+                                        <p:attrNameLst>
+                                          <p:attrName>style.visibility</p:attrName>
+                                        </p:attrNameLst>
+                                      </p:cBhvr>
+                                      <p:to>
+                                        <p:strVal val="visible"/>
+                                      </p:to>
+                                    </p:set>
+                                  </p:childTnLst>
+                                </p:cTn>
+                              </p:par>
+                              <p:par>
+                                <p:cTn id="14" presetID="1" presetClass="entr" presetSubtype="0" fill="hold" grpId="0" nodeType="withEffect">
+                                  <p:stCondLst>
+                                    <p:cond delay="0"/>
+                                  </p:stCondLst>
+                                  <p:childTnLst>
+                                    <p:set>
+                                      <p:cBhvr>
+                                        <p:cTn id="13" dur="1" fill="hold">
+                                          <p:stCondLst>
+                                            <p:cond delay="0"/>
+                                          </p:stCondLst>
+                                        </p:cTn>
+                                        <p:tgtEl>
+                                          <p:spTgt spid="15"/>
+                                        </p:tgtEl>
+                                        <p:attrNameLst>
+                                          <p:attrName>style.visibility</p:attrName>
+                                        </p:attrNameLst>
+                                      </p:cBhvr>
+                                      <p:to>
+                                        <p:strVal val="visible"/>
+                                      </p:to>
+                                    </p:set>
+                                  </p:childTnLst>
+                                </p:cTn>
+                              </p:par>
+                              <p:par>
+                                <p:cTn id="16" presetID="1" presetClass="entr" presetSubtype="0" fill="hold" grpId="0" nodeType="withEffect">
+                                  <p:stCondLst>
+                                    <p:cond delay="0"/>
+                                  </p:stCondLst>
+                                  <p:childTnLst>
+                                    <p:set>
+                                      <p:cBhvr>
+                                        <p:cTn id="15" dur="1" fill="hold">
+                                          <p:stCondLst>
+                                            <p:cond delay="0"/>
+                                          </p:stCondLst>
+                                        </p:cTn>
+                                        <p:tgtEl>
+                                          <p:spTgt spid="16"/>
+                                        </p:tgtEl>
+                                        <p:attrNameLst>
+                                          <p:attrName>style.visibility</p:attrName>
+                                        </p:attrNameLst>
+                                      </p:cBhvr>
+                                      <p:to>
+                                        <p:strVal val="visible"/>
+                                      </p:to>
+                                    </p:set>
+                                  </p:childTnLst>
+                                </p:cTn>
+                              </p:par>
+                            </p:childTnLst>
+                          </p:cTn>
+                        </p:par>
+                      </p:childTnLst>
+                    </p:cTn>
+                  </p:par>
+                  <p:par>
+                    <p:cTn id="17" fill="hold">
+                      <p:stCondLst>
+                        <p:cond delay="indefinite"/>
+                      </p:stCondLst>
+                      <p:childTnLst>
+                        <p:par>
+                          <p:cTn id="18" fill="hold">
+                            <p:stCondLst>
+                              <p:cond delay="0"/>
+                            </p:stCondLst>
+                            <p:childTnLst>
+                              <p:par>
+                                <p:cTn id="20" presetID="1" presetClass="entr" presetSubtype="0" fill="hold" grpId="0" nodeType="clickEffect">
+                                  <p:stCondLst>
+                                    <p:cond delay="0"/>
+                                  </p:stCondLst>
+                                  <p:childTnLst>
+                                    <p:set>
+                                      <p:cBhvr>
+                                        <p:cTn id="19" dur="1" fill="hold">
+                                          <p:stCondLst>
+                                            <p:cond delay="0"/>
+                                          </p:stCondLst>
+                                        </p:cTn>
+                                        <p:tgtEl>
+                                          <p:spTgt spid="17"/>
+                                        </p:tgtEl>
+                                        <p:attrNameLst>
+                                          <p:attrName>style.visibility</p:attrName>
+                                        </p:attrNameLst>
+                                      </p:cBhvr>
+                                      <p:to>
+                                        <p:strVal val="visible"/>
+                                      </p:to>
+                                    </p:set>
+                                  </p:childTnLst>
+                                </p:cTn>
+                              </p:par>
+                              <p:par>
+                                <p:cTn id="22" presetID="1" presetClass="entr" presetSubtype="0" fill="hold" grpId="0" nodeType="withEffect">
+                                  <p:stCondLst>
+                                    <p:cond delay="0"/>
+                                  </p:stCondLst>
+                                  <p:childTnLst>
+                                    <p:set>
+                                      <p:cBhvr>
+                                        <p:cTn id="21" dur="1" fill="hold">
+                                          <p:stCondLst>
+                                            <p:cond delay="0"/>
+                                          </p:stCondLst>
+                                        </p:cTn>
+                                        <p:tgtEl>
+                                          <p:spTgt spid="18"/>
+                                        </p:tgtEl>
+                                        <p:attrNameLst>
+                                          <p:attrName>style.visibility</p:attrName>
+                                        </p:attrNameLst>
+                                      </p:cBhvr>
+                                      <p:to>
+                                        <p:strVal val="visible"/>
+                                      </p:to>
+                                    </p:set>
+                                  </p:childTnLst>
+                                </p:cTn>
+                              </p:par>
+                              <p:par>
+                                <p:cTn id="24" presetID="1" presetClass="entr" presetSubtype="0" fill="hold" nodeType="withEffect">
+                                  <p:stCondLst>
+                                    <p:cond delay="0"/>
+                                  </p:stCondLst>
+                                  <p:childTnLst>
+                                    <p:set>
+                                      <p:cBhvr>
+                                        <p:cTn id="23" dur="1" fill="hold">
+                                          <p:stCondLst>
+                                            <p:cond delay="0"/>
+                                          </p:stCondLst>
+                                        </p:cTn>
+                                        <p:tgtEl>
+                                          <p:spTgt spid="19"/>
+                                        </p:tgtEl>
+                                        <p:attrNameLst>
+                                          <p:attrName>style.visibility</p:attrName>
+                                        </p:attrNameLst>
+                                      </p:cBhvr>
+                                      <p:to>
+                                        <p:strVal val="visible"/>
+                                      </p:to>
+                                    </p:set>
+                                  </p:childTnLst>
+                                </p:cTn>
+                              </p:par>
+                              <p:par>
+                                <p:cTn id="26" presetID="1" presetClass="entr" presetSubtype="0" fill="hold" grpId="0" nodeType="withEffect">
+                                  <p:stCondLst>
+                                    <p:cond delay="0"/>
+                                  </p:stCondLst>
+                                  <p:childTnLst>
+                                    <p:set>
+                                      <p:cBhvr>
+                                        <p:cTn id="25" dur="1" fill="hold">
+                                          <p:stCondLst>
+                                            <p:cond delay="0"/>
+                                          </p:stCondLst>
+                                        </p:cTn>
+                                        <p:tgtEl>
+                                          <p:spTgt spid="20"/>
+                                        </p:tgtEl>
+                                        <p:attrNameLst>
+                                          <p:attrName>style.visibility</p:attrName>
+                                        </p:attrNameLst>
+                                      </p:cBhvr>
+                                      <p:to>
+                                        <p:strVal val="visible"/>
+                                      </p:to>
+                                    </p:set>
+                                  </p:childTnLst>
+                                </p:cTn>
+                              </p:par>
+                              <p:par>
+                                <p:cTn id="28" presetID="1" presetClass="entr" presetSubtype="0" fill="hold" grpId="0" nodeType="withEffect">
+                                  <p:stCondLst>
+                                    <p:cond delay="0"/>
+                                  </p:stCondLst>
+                                  <p:childTnLst>
+                                    <p:set>
+                                      <p:cBhvr>
+                                        <p:cTn id="27" dur="1" fill="hold">
+                                          <p:stCondLst>
+                                            <p:cond delay="0"/>
+                                          </p:stCondLst>
+                                        </p:cTn>
+                                        <p:tgtEl>
+                                          <p:spTgt spid="21"/>
+                                        </p:tgtEl>
+                                        <p:attrNameLst>
+                                          <p:attrName>style.visibility</p:attrName>
+                                        </p:attrNameLst>
+                                      </p:cBhvr>
+                                      <p:to>
+                                        <p:strVal val="visible"/>
+                                      </p:to>
+                                    </p:set>
+                                  </p:childTnLst>
+                                </p:cTn>
+                              </p:par>
+                            </p:childTnLst>
+                          </p:cTn>
+                        </p:par>
+                      </p:childTnLst>
+                    </p:cTn>
+                  </p:par>
+                  <p:par>
+                    <p:cTn id="29" fill="hold">
+                      <p:stCondLst>
+                        <p:cond delay="indefinite"/>
+                      </p:stCondLst>
+                      <p:childTnLst>
+                        <p:par>
+                          <p:cTn id="30" fill="hold">
+                            <p:stCondLst>
+                              <p:cond delay="0"/>
+                            </p:stCondLst>
+                            <p:childTnLst>
+                              <p:par>
+                                <p:cTn id="32" presetID="1" presetClass="entr" presetSubtype="0" fill="hold" grpId="0" nodeType="clickEffect">
+                                  <p:stCondLst>
+                                    <p:cond delay="0"/>
+                                  </p:stCondLst>
+                                  <p:childTnLst>
+                                    <p:set>
+                                      <p:cBhvr>
+                                        <p:cTn id="31" dur="1" fill="hold">
+                                          <p:stCondLst>
+                                            <p:cond delay="0"/>
+                                          </p:stCondLst>
+                                        </p:cTn>
+                                        <p:tgtEl>
+                                          <p:spTgt spid="22"/>
+                                        </p:tgtEl>
+                                        <p:attrNameLst>
+                                          <p:attrName>style.visibility</p:attrName>
+                                        </p:attrNameLst>
+                                      </p:cBhvr>
+                                      <p:to>
+                                        <p:strVal val="visible"/>
+                                      </p:to>
+                                    </p:set>
+                                  </p:childTnLst>
+                                </p:cTn>
+                              </p:par>
+                              <p:par>
+                                <p:cTn id="34" presetID="1" presetClass="entr" presetSubtype="0" fill="hold" grpId="0" nodeType="withEffect">
+                                  <p:stCondLst>
+                                    <p:cond delay="0"/>
+                                  </p:stCondLst>
+                                  <p:childTnLst>
+                                    <p:set>
+                                      <p:cBhvr>
+                                        <p:cTn id="33" dur="1" fill="hold">
+                                          <p:stCondLst>
+                                            <p:cond delay="0"/>
+                                          </p:stCondLst>
+                                        </p:cTn>
+                                        <p:tgtEl>
+                                          <p:spTgt spid="23"/>
+                                        </p:tgtEl>
+                                        <p:attrNameLst>
+                                          <p:attrName>style.visibility</p:attrName>
+                                        </p:attrNameLst>
+                                      </p:cBhvr>
+                                      <p:to>
+                                        <p:strVal val="visible"/>
+                                      </p:to>
+                                    </p:set>
+                                  </p:childTnLst>
+                                </p:cTn>
+                              </p:par>
+                            </p:childTnLst>
+                          </p:cTn>
+                        </p:par>
+                      </p:childTnLst>
+                    </p:cTn>
+                  </p:par>
+                </p:childTnLst>
+              </p:cTn>
+              <p:prevCondLst>
+                <p:cond evt="onPrev" delay="0">
+                  <p:tgtEl>
+                    <p:sldTgt/>
+                  </p:tgtEl>
+                </p:cond>
+              </p:prevCondLst>
+              <p:nextCondLst>
+                <p:cond evt="onNext" delay="0">
+                  <p:tgtEl>
+                    <p:sldTgt/>
+                  </p:tgtEl>
+                </p:cond>
+              </p:nextCondLst>
+            </p:seq>
+          </p:childTnLst>
+        </p:cTn>
+      </p:par>
+    </p:tnLst>
+    <p:bldLst>
+      <p:bldP spid="11" grpId="0" animBg="1"/>
+      <p:bldP spid="12" grpId="0" animBg="1"/>
+      <p:bldP spid="14" grpId="0" animBg="1"/>
+      <p:bldP spid="15" grpId="0" animBg="1"/>
+      <p:bldP spid="16" grpId="0" animBg="1"/>
+      <p:bldP spid="17" grpId="0" animBg="1"/>
+      <p:bldP spid="18" grpId="0" animBg="1"/>
+      <p:bldP spid="20" grpId="0" animBg="1"/>
+      <p:bldP spid="21" grpId="0" animBg="1"/>
+      <p:bldP spid="22" grpId="0" animBg="1"/>
+      <p:bldP spid="23" grpId="0" animBg="1"/>
+    </p:bldLst>
+  </p:timing>
 </p:sld>
 </file>
 
@@ -23822,7 +25611,7 @@
       </p:sp>
       <p:sp>
         <p:nvSpPr>
-          <p:cNvPr id="9" name="Text 6"/>
+          <p:cNvPr id="9" name="click-1:fade"/>
           <p:cNvSpPr/>
           <p:nvPr/>
         </p:nvSpPr>
@@ -23976,7 +25765,7 @@
       </p:sp>
       <p:sp>
         <p:nvSpPr>
-          <p:cNvPr id="14" name="Text 10"/>
+          <p:cNvPr id="14" name="click-1:fade"/>
           <p:cNvSpPr/>
           <p:nvPr/>
         </p:nvSpPr>
@@ -24130,7 +25919,7 @@
       </p:sp>
       <p:sp>
         <p:nvSpPr>
-          <p:cNvPr id="19" name="Text 14"/>
+          <p:cNvPr id="19" name="click-1:fade"/>
           <p:cNvSpPr/>
           <p:nvPr/>
         </p:nvSpPr>
@@ -24284,7 +26073,7 @@
       </p:sp>
       <p:sp>
         <p:nvSpPr>
-          <p:cNvPr id="24" name="Text 18"/>
+          <p:cNvPr id="24" name="click-1:fade"/>
           <p:cNvSpPr/>
           <p:nvPr/>
         </p:nvSpPr>
@@ -24438,7 +26227,7 @@
       </p:sp>
       <p:sp>
         <p:nvSpPr>
-          <p:cNvPr id="29" name="Text 22"/>
+          <p:cNvPr id="29" name="click-1:fade"/>
           <p:cNvSpPr/>
           <p:nvPr/>
         </p:nvSpPr>
@@ -24592,7 +26381,7 @@
       </p:sp>
       <p:sp>
         <p:nvSpPr>
-          <p:cNvPr id="34" name="Text 26"/>
+          <p:cNvPr id="34" name="click-1:fade"/>
           <p:cNvSpPr/>
           <p:nvPr/>
         </p:nvSpPr>
@@ -24746,7 +26535,7 @@
       </p:sp>
       <p:sp>
         <p:nvSpPr>
-          <p:cNvPr id="39" name="Text 30"/>
+          <p:cNvPr id="39" name="click-1:fade"/>
           <p:cNvSpPr/>
           <p:nvPr/>
         </p:nvSpPr>
@@ -24900,7 +26689,7 @@
       </p:sp>
       <p:sp>
         <p:nvSpPr>
-          <p:cNvPr id="44" name="Text 34"/>
+          <p:cNvPr id="44" name="click-1:fade"/>
           <p:cNvSpPr/>
           <p:nvPr/>
         </p:nvSpPr>
@@ -25054,7 +26843,7 @@
       </p:sp>
       <p:sp>
         <p:nvSpPr>
-          <p:cNvPr id="49" name="Text 38"/>
+          <p:cNvPr id="49" name="click-1:fade"/>
           <p:cNvSpPr/>
           <p:nvPr/>
         </p:nvSpPr>
@@ -25177,6 +26966,380 @@
   <p:clrMapOvr>
     <a:masterClrMapping/>
   </p:clrMapOvr>
+  <p:timing>
+    <p:tnLst>
+      <p:par>
+        <p:cTn id="1" dur="indefinite" restart="never" nodeType="tmRoot">
+          <p:childTnLst>
+            <p:seq concurrent="1" nextAc="seek">
+              <p:cTn id="2" dur="indefinite" nodeType="mainSeq">
+                <p:childTnLst>
+                  <p:par>
+                    <p:cTn id="3" fill="hold">
+                      <p:stCondLst>
+                        <p:cond delay="indefinite"/>
+                      </p:stCondLst>
+                      <p:childTnLst>
+                        <p:par>
+                          <p:cTn id="4" fill="hold">
+                            <p:stCondLst>
+                              <p:cond delay="0"/>
+                            </p:stCondLst>
+                            <p:childTnLst>
+                              <p:par>
+                                <p:cTn id="6" presetID="10" presetClass="entr" presetSubtype="0" fill="hold" grpId="0" nodeType="clickEffect">
+                                  <p:stCondLst>
+                                    <p:cond delay="0"/>
+                                  </p:stCondLst>
+                                  <p:childTnLst>
+                                    <p:set>
+                                      <p:cBhvr>
+                                        <p:cTn id="5" dur="1" fill="hold">
+                                          <p:stCondLst>
+                                            <p:cond delay="0"/>
+                                          </p:stCondLst>
+                                        </p:cTn>
+                                        <p:tgtEl>
+                                          <p:spTgt spid="9"/>
+                                        </p:tgtEl>
+                                        <p:attrNameLst>
+                                          <p:attrName>style.visibility</p:attrName>
+                                        </p:attrNameLst>
+                                      </p:cBhvr>
+                                      <p:to>
+                                        <p:strVal val="visible"/>
+                                      </p:to>
+                                    </p:set>
+                                    <p:animEffect transition="in" filter="fade">
+                                      <p:cBhvr>
+                                        <p:cTn id="7" dur="500"/>
+                                        <p:tgtEl>
+                                          <p:spTgt spid="9"/>
+                                        </p:tgtEl>
+                                      </p:cBhvr>
+                                    </p:animEffect>
+                                  </p:childTnLst>
+                                </p:cTn>
+                              </p:par>
+                              <p:par>
+                                <p:cTn id="9" presetID="10" presetClass="entr" presetSubtype="0" fill="hold" grpId="0" nodeType="withEffect">
+                                  <p:stCondLst>
+                                    <p:cond delay="0"/>
+                                  </p:stCondLst>
+                                  <p:childTnLst>
+                                    <p:set>
+                                      <p:cBhvr>
+                                        <p:cTn id="8" dur="1" fill="hold">
+                                          <p:stCondLst>
+                                            <p:cond delay="0"/>
+                                          </p:stCondLst>
+                                        </p:cTn>
+                                        <p:tgtEl>
+                                          <p:spTgt spid="14"/>
+                                        </p:tgtEl>
+                                        <p:attrNameLst>
+                                          <p:attrName>style.visibility</p:attrName>
+                                        </p:attrNameLst>
+                                      </p:cBhvr>
+                                      <p:to>
+                                        <p:strVal val="visible"/>
+                                      </p:to>
+                                    </p:set>
+                                    <p:animEffect transition="in" filter="fade">
+                                      <p:cBhvr>
+                                        <p:cTn id="10" dur="500"/>
+                                        <p:tgtEl>
+                                          <p:spTgt spid="14"/>
+                                        </p:tgtEl>
+                                      </p:cBhvr>
+                                    </p:animEffect>
+                                  </p:childTnLst>
+                                </p:cTn>
+                              </p:par>
+                              <p:par>
+                                <p:cTn id="12" presetID="10" presetClass="entr" presetSubtype="0" fill="hold" grpId="0" nodeType="withEffect">
+                                  <p:stCondLst>
+                                    <p:cond delay="0"/>
+                                  </p:stCondLst>
+                                  <p:childTnLst>
+                                    <p:set>
+                                      <p:cBhvr>
+                                        <p:cTn id="11" dur="1" fill="hold">
+                                          <p:stCondLst>
+                                            <p:cond delay="0"/>
+                                          </p:stCondLst>
+                                        </p:cTn>
+                                        <p:tgtEl>
+                                          <p:spTgt spid="19"/>
+                                        </p:tgtEl>
+                                        <p:attrNameLst>
+                                          <p:attrName>style.visibility</p:attrName>
+                                        </p:attrNameLst>
+                                      </p:cBhvr>
+                                      <p:to>
+                                        <p:strVal val="visible"/>
+                                      </p:to>
+                                    </p:set>
+                                    <p:animEffect transition="in" filter="fade">
+                                      <p:cBhvr>
+                                        <p:cTn id="13" dur="500"/>
+                                        <p:tgtEl>
+                                          <p:spTgt spid="19"/>
+                                        </p:tgtEl>
+                                      </p:cBhvr>
+                                    </p:animEffect>
+                                  </p:childTnLst>
+                                </p:cTn>
+                              </p:par>
+                              <p:par>
+                                <p:cTn id="15" presetID="10" presetClass="entr" presetSubtype="0" fill="hold" grpId="0" nodeType="withEffect">
+                                  <p:stCondLst>
+                                    <p:cond delay="0"/>
+                                  </p:stCondLst>
+                                  <p:childTnLst>
+                                    <p:set>
+                                      <p:cBhvr>
+                                        <p:cTn id="14" dur="1" fill="hold">
+                                          <p:stCondLst>
+                                            <p:cond delay="0"/>
+                                          </p:stCondLst>
+                                        </p:cTn>
+                                        <p:tgtEl>
+                                          <p:spTgt spid="24"/>
+                                        </p:tgtEl>
+                                        <p:attrNameLst>
+                                          <p:attrName>style.visibility</p:attrName>
+                                        </p:attrNameLst>
+                                      </p:cBhvr>
+                                      <p:to>
+                                        <p:strVal val="visible"/>
+                                      </p:to>
+                                    </p:set>
+                                    <p:animEffect transition="in" filter="fade">
+                                      <p:cBhvr>
+                                        <p:cTn id="16" dur="500"/>
+                                        <p:tgtEl>
+                                          <p:spTgt spid="24"/>
+                                        </p:tgtEl>
+                                      </p:cBhvr>
+                                    </p:animEffect>
+                                  </p:childTnLst>
+                                </p:cTn>
+                              </p:par>
+                              <p:par>
+                                <p:cTn id="18" presetID="10" presetClass="entr" presetSubtype="0" fill="hold" grpId="0" nodeType="withEffect">
+                                  <p:stCondLst>
+                                    <p:cond delay="0"/>
+                                  </p:stCondLst>
+                                  <p:childTnLst>
+                                    <p:set>
+                                      <p:cBhvr>
+                                        <p:cTn id="17" dur="1" fill="hold">
+                                          <p:stCondLst>
+                                            <p:cond delay="0"/>
+                                          </p:stCondLst>
+                                        </p:cTn>
+                                        <p:tgtEl>
+                                          <p:spTgt spid="29"/>
+                                        </p:tgtEl>
+                                        <p:attrNameLst>
+                                          <p:attrName>style.visibility</p:attrName>
+                                        </p:attrNameLst>
+                                      </p:cBhvr>
+                                      <p:to>
+                                        <p:strVal val="visible"/>
+                                      </p:to>
+                                    </p:set>
+                                    <p:animEffect transition="in" filter="fade">
+                                      <p:cBhvr>
+                                        <p:cTn id="19" dur="500"/>
+                                        <p:tgtEl>
+                                          <p:spTgt spid="29"/>
+                                        </p:tgtEl>
+                                      </p:cBhvr>
+                                    </p:animEffect>
+                                  </p:childTnLst>
+                                </p:cTn>
+                              </p:par>
+                              <p:par>
+                                <p:cTn id="21" presetID="10" presetClass="entr" presetSubtype="0" fill="hold" grpId="0" nodeType="withEffect">
+                                  <p:stCondLst>
+                                    <p:cond delay="0"/>
+                                  </p:stCondLst>
+                                  <p:childTnLst>
+                                    <p:set>
+                                      <p:cBhvr>
+                                        <p:cTn id="20" dur="1" fill="hold">
+                                          <p:stCondLst>
+                                            <p:cond delay="0"/>
+                                          </p:stCondLst>
+                                        </p:cTn>
+                                        <p:tgtEl>
+                                          <p:spTgt spid="34"/>
+                                        </p:tgtEl>
+                                        <p:attrNameLst>
+                                          <p:attrName>style.visibility</p:attrName>
+                                        </p:attrNameLst>
+                                      </p:cBhvr>
+                                      <p:to>
+                                        <p:strVal val="visible"/>
+                                      </p:to>
+                                    </p:set>
+                                    <p:animEffect transition="in" filter="fade">
+                                      <p:cBhvr>
+                                        <p:cTn id="22" dur="500"/>
+                                        <p:tgtEl>
+                                          <p:spTgt spid="34"/>
+                                        </p:tgtEl>
+                                      </p:cBhvr>
+                                    </p:animEffect>
+                                  </p:childTnLst>
+                                </p:cTn>
+                              </p:par>
+                              <p:par>
+                                <p:cTn id="24" presetID="10" presetClass="entr" presetSubtype="0" fill="hold" grpId="0" nodeType="withEffect">
+                                  <p:stCondLst>
+                                    <p:cond delay="0"/>
+                                  </p:stCondLst>
+                                  <p:childTnLst>
+                                    <p:set>
+                                      <p:cBhvr>
+                                        <p:cTn id="23" dur="1" fill="hold">
+                                          <p:stCondLst>
+                                            <p:cond delay="0"/>
+                                          </p:stCondLst>
+                                        </p:cTn>
+                                        <p:tgtEl>
+                                          <p:spTgt spid="39"/>
+                                        </p:tgtEl>
+                                        <p:attrNameLst>
+                                          <p:attrName>style.visibility</p:attrName>
+                                        </p:attrNameLst>
+                                      </p:cBhvr>
+                                      <p:to>
+                                        <p:strVal val="visible"/>
+                                      </p:to>
+                                    </p:set>
+                                    <p:animEffect transition="in" filter="fade">
+                                      <p:cBhvr>
+                                        <p:cTn id="25" dur="500"/>
+                                        <p:tgtEl>
+                                          <p:spTgt spid="39"/>
+                                        </p:tgtEl>
+                                      </p:cBhvr>
+                                    </p:animEffect>
+                                  </p:childTnLst>
+                                </p:cTn>
+                              </p:par>
+                              <p:par>
+                                <p:cTn id="27" presetID="10" presetClass="entr" presetSubtype="0" fill="hold" grpId="0" nodeType="withEffect">
+                                  <p:stCondLst>
+                                    <p:cond delay="0"/>
+                                  </p:stCondLst>
+                                  <p:childTnLst>
+                                    <p:set>
+                                      <p:cBhvr>
+                                        <p:cTn id="26" dur="1" fill="hold">
+                                          <p:stCondLst>
+                                            <p:cond delay="0"/>
+                                          </p:stCondLst>
+                                        </p:cTn>
+                                        <p:tgtEl>
+                                          <p:spTgt spid="44"/>
+                                        </p:tgtEl>
+                                        <p:attrNameLst>
+                                          <p:attrName>style.visibility</p:attrName>
+                                        </p:attrNameLst>
+                                      </p:cBhvr>
+                                      <p:to>
+                                        <p:strVal val="visible"/>
+                                      </p:to>
+                                    </p:set>
+                                    <p:animEffect transition="in" filter="fade">
+                                      <p:cBhvr>
+                                        <p:cTn id="28" dur="500"/>
+                                        <p:tgtEl>
+                                          <p:spTgt spid="44"/>
+                                        </p:tgtEl>
+                                      </p:cBhvr>
+                                    </p:animEffect>
+                                  </p:childTnLst>
+                                </p:cTn>
+                              </p:par>
+                              <p:par>
+                                <p:cTn id="30" presetID="10" presetClass="entr" presetSubtype="0" fill="hold" grpId="0" nodeType="withEffect">
+                                  <p:stCondLst>
+                                    <p:cond delay="0"/>
+                                  </p:stCondLst>
+                                  <p:childTnLst>
+                                    <p:set>
+                                      <p:cBhvr>
+                                        <p:cTn id="29" dur="1" fill="hold">
+                                          <p:stCondLst>
+                                            <p:cond delay="0"/>
+                                          </p:stCondLst>
+                                        </p:cTn>
+                                        <p:tgtEl>
+                                          <p:spTgt spid="49"/>
+                                        </p:tgtEl>
+                                        <p:attrNameLst>
+                                          <p:attrName>style.visibility</p:attrName>
+                                        </p:attrNameLst>
+                                      </p:cBhvr>
+                                      <p:to>
+                                        <p:strVal val="visible"/>
+                                      </p:to>
+                                    </p:set>
+                                    <p:animEffect transition="in" filter="fade">
+                                      <p:cBhvr>
+                                        <p:cTn id="31" dur="500"/>
+                                        <p:tgtEl>
+                                          <p:spTgt spid="49"/>
+                                        </p:tgtEl>
+                                      </p:cBhvr>
+                                    </p:animEffect>
+                                  </p:childTnLst>
+                                </p:cTn>
+                              </p:par>
+                            </p:childTnLst>
+                          </p:cTn>
+                        </p:par>
+                      </p:childTnLst>
+                    </p:cTn>
+                  </p:par>
+                </p:childTnLst>
+              </p:cTn>
+              <p:prevCondLst>
+                <p:cond evt="onPrev" delay="0">
+                  <p:tgtEl>
+                    <p:sldTgt/>
+                  </p:tgtEl>
+                </p:cond>
+              </p:prevCondLst>
+              <p:nextCondLst>
+                <p:cond evt="onNext" delay="0">
+                  <p:tgtEl>
+                    <p:sldTgt/>
+                  </p:tgtEl>
+                </p:cond>
+              </p:nextCondLst>
+            </p:seq>
+          </p:childTnLst>
+        </p:cTn>
+      </p:par>
+    </p:tnLst>
+    <p:bldLst>
+      <p:bldP spid="9" grpId="0" animBg="1"/>
+      <p:bldP spid="14" grpId="0" animBg="1"/>
+      <p:bldP spid="19" grpId="0" animBg="1"/>
+      <p:bldP spid="24" grpId="0" animBg="1"/>
+      <p:bldP spid="29" grpId="0" animBg="1"/>
+      <p:bldP spid="34" grpId="0" animBg="1"/>
+      <p:bldP spid="39" grpId="0" animBg="1"/>
+      <p:bldP spid="44" grpId="0" animBg="1"/>
+      <p:bldP spid="49" grpId="0" animBg="1"/>
+    </p:bldLst>
+  </p:timing>
 </p:sld>
 </file>
 

</xml_diff>